<commit_message>
Polish submission repository with demo screenshots and voiceover guide
</commit_message>
<xml_diff>
--- a/presentation/Njia-Dhruzzz.pptx
+++ b/presentation/Njia-Dhruzzz.pptx
@@ -859,7 +859,7 @@
           <a:lstStyle/>
           <a:p>
             <a:r>
-              <a:t>Main implementation owner confirms 72 passing backend unit-test methods. Separately, coach-acceptance-results.json records 48 passing public acceptance assertions and njia-coach-demo-results.json records nine passing recording assertions, totaling 57 new public assertions. No mocked responses. Desktop, mobile and recording used Groq openai/gpt-oss-20b. Observed elapsed times were 2.259 seconds desktop, 1.318 mobile and 2.260 recording including PDF processing; these are individual observations, not a latency benchmark. All three runs recorded no JavaScript errors and all observed API responses succeeded. The sample used 391 Kenya Data Analyst postings and returned 39.6% demand-weighted coverage, not hiring odds. Recording is exactly 90 seconds at normal speed. Semantic factuality is not guaranteed: the recorded rewrite added unsupported real-time sales monitoring, despite number/tool checks. Human review is required. No real-user adoption or employment impact is claimed.</a:t>
+              <a:t>Main implementation owner confirms 73 passing backend unit-test methods. Separately, coach-acceptance-results.json records 48 passing public acceptance assertions and njia-coach-demo-results.json records nine passing recording assertions, totaling 57 new public assertions. No mocked responses. Desktop, mobile and recording used Groq openai/gpt-oss-20b. Observed elapsed times were 2.259 seconds desktop, 1.318 mobile and 2.260 recording including PDF processing; these are individual observations, not a latency benchmark. All three runs recorded no JavaScript errors and all observed API responses succeeded. The sample used 391 Kenya Data Analyst postings and returned 39.6% demand-weighted coverage, not hiring odds. Recording is exactly 90 seconds at normal speed. Semantic factuality is not guaranteed: the recorded rewrite added unsupported real-time sales monitoring, despite number/tool checks. Human review is required. No real-user adoption or employment impact is claimed.</a:t>
             </a:r>
           </a:p>
         </p:txBody>
@@ -999,7 +999,7 @@
           <a:lstStyle/>
           <a:p>
             <a:r>
-              <a:t>Close with the live product and source repository. Team: Eeshan Vaghjiani, Bhavin Mepani and Dhruvin Bhudia; Kenya ONLINE. The new recorded production demo is verified locally at exactly 90 seconds, normal speed, with captions. Slide 8 links to the expected demo-v1 release asset njia-demo-90s.webm; upload of the updated asset is pending confirmation. Ask for a Kenyan learner or training partner to run the proposed pilot.</a:t>
+              <a:t>Close with the live product and source repository. Team: Eeshan Vaghjiani, Bhavin Mepani and Dhruvin Bhudia; Kenya ONLINE. The new recorded production demo is verified locally at exactly 90 seconds, normal speed, with captions. Slide 8 links to the published demo-v1 release asset: https://github.com/Eeshan-Vaghjiani/njia/releases/download/demo-v1/njia-demo-90s.webm. Ask for a Kenyan learner or training partner to run the proposed pilot.</a:t>
             </a:r>
           </a:p>
         </p:txBody>
@@ -12062,7 +12062,7 @@
                 </a:solidFill>
                 <a:latin typeface="Georgia"/>
               </a:rPr>
-              <a:t>72</a:t>
+              <a:t>73</a:t>
             </a:r>
           </a:p>
         </p:txBody>
@@ -14753,7 +14753,7 @@
                 <a:latin typeface="Segoe UI"/>
                 <a:hlinkClick r:id="rId4"/>
               </a:rPr>
-              <a:t>njia-demo-90s.webm · release upload pending</a:t>
+              <a:t>njia-demo-90s.webm · published</a:t>
             </a:r>
           </a:p>
         </p:txBody>

</xml_diff>

<commit_message>
Verify NVIDIA fallback and publish refreshed MP4 demo and slides
</commit_message>
<xml_diff>
--- a/presentation/Njia-Dhruzzz.pptx
+++ b/presentation/Njia-Dhruzzz.pptx
@@ -509,7 +509,7 @@
           <a:lstStyle/>
           <a:p>
             <a:r>
-              <a:t>Njia means path in Swahili. We are Dhruzzz, a Kenya ONLINE team. Wanjiru is an illustrative persona, not an interviewed user. The working production advisor connects CV evidence to historical country-and-role demand, suggested CV rewrites and a seven-day plan. Public desktop, mobile and recording runs used real Groq inference; the evidence is summarized on slide 6.</a:t>
+              <a:t>Njia means path in Swahili. We are Dhruzzz, a Kenya ONLINE team. Wanjiru is an illustrative persona, not an interviewed user. Njia now asks before it advises: after the CV is provided, it asks a few follow-up questions, then links strengths to CV evidence and the learner's own answers, sets three priorities from historical 2023 Kenya role data, and suggests fact-preserving CV rewrites and a seven-day plan. It also answers two new questions: which jobs can I apply for now, and am I ready for the interview? Skill-match percentages measure skill overlap and are not a hiring probability. Evidence and limits are on slide 6.</a:t>
             </a:r>
           </a:p>
         </p:txBody>
@@ -579,7 +579,7 @@
           <a:lstStyle/>
           <a:p>
             <a:r>
-              <a:t>This is a hand-authored illustration of the intended assessment output, not a captured model response. Both bullets use the same facts: cleaned sales data in Excel and built weekly charts. There is no invented business impact, percentage or credential. The SQL recommendation is an illustrative gap when SQL is not evidenced in the CV; absence of CV evidence does not mean absence of ability. The current upgrade adds a tailored seven-day action plan and interview question.</a:t>
+              <a:t>The product story is Ask, Match, Practise. Ask: after the CV is provided, the AI asks three to five follow-up questions: skill questions with the options Used it at work, Used it in a project or course, Still learning it, or Not yet, plus a free-text question about an outcome. Answers reshape the suggested skills and the brief. The before/after example is a hand-authored illustration, not a captured model response. The rewrite uses only the CV line and the learner's own answer; anything drawn from an answer is labelled Uses your answer — verify. No business impact, percentage or credential is invented. Match: live postings the learner can apply for, each with a skill-match percentage, matched and missing skills, and a link to apply on the source. Practise: interview questions candidates report on the web, each with its source link, then typed practice with AI feedback. The seven-day checklist can also be sent to WhatsApp.</a:t>
             </a:r>
           </a:p>
         </p:txBody>
@@ -649,7 +649,7 @@
           <a:lstStyle/>
           <a:p>
             <a:r>
-              <a:t>The chart is recalculated directly from data/africa_jobs_subset.jsonl. The full subset has 18,371 postings across ten countries, including 1,326 Kenyan postings across roles. The denominator for this chart is 391 Kenya Data Analyst postings. A posting may mention several skills, so the bars are not parts of a total. Source: Hugging Face lukebarousse/data_jobs, Apache-2.0, 2023. This is a historical job-posting sample, not live hiring demand or a representative census of Kenya's labor market.</a:t>
+              <a:t>The chart is recalculated directly from data/africa_jobs_subset.jsonl. The full subset has 18,371 postings across ten countries, including 1,326 Kenyan postings across roles. The denominator for this chart is 391 Kenya Data Analyst postings. A posting may mention several skills, so the bars are not parts of a total. Source: Hugging Face lukebarousse/data_jobs, Apache-2.0, 2023. This is a historical job-posting sample, not live hiring demand or a representative census of Kenya's labor market. It sets the three priorities in the brief. Live openings are a separate feature, shown on slide 5, and never change these historical figures.</a:t>
             </a:r>
           </a:p>
         </p:txBody>
@@ -719,7 +719,7 @@
           <a:lstStyle/>
           <a:p>
             <a:r>
-              <a:t>Public production desktop, mobile and recording runs confirmed Groq, openai/gpt-oss-20b. User opts in before CV text is sent to the external AI provider, after basic PII redaction. Redaction is best-effort rather than full anonymization. There is no application database persistence of the CV; this does not make a provider-retention claim. The advisor validates output shape, supported skill IDs and source quotes, and checks newly introduced numbers/tools in rewrites. These checks do not prove semantic factuality: the recorded rewrite added unsupported real-time sales monitoring. Human factual review remains necessary. Rules-based guidance is the fallback when the model is unavailable or output is rejected.</a:t>
+              <a:t>The brief uses Groq-hosted openai/gpt-oss-20b; public production desktop, mobile and recording runs of the earlier release confirmed this model. CV text goes to the AI provider only after opt-in and basic, best-effort PII redaction, which is not full anonymization. There is no application database persistence of the CV; this is not a provider-retention claim. New today: the AI asks three to five follow-up questions after the CV, and the answers reshape suggested skills and the brief. Remote jobs come from the Himalayas public jobs API, filtered to postings whose location restrictions include the user's country or worldwide. Local postings and reported interview questions come from Groq's built-in browser search; a web result is kept only when its URL appears in the search tool's evidence. Web searches receive only role, country and skill names, never CV text. Practice answers need separate consent, and feedback outlines use placeholders such as [your result] instead of inventing facts. Any provider failure falls back to clearly labelled curated or deterministic output. These checks do not prove semantic factuality: an earlier recorded rewrite added unsupported real-time sales monitoring, so human factual review remains necessary. For JSON coaching calls (follow-ups, brief and practice feedback), Groq failure can trigger one NVIDIA API Catalog request using the same openai/gpt-oss-20b model; returned provenance names the actual provider. Web research uses the separate openai/gpt-oss-120b search model on Groq and has no NVIDIA browser-search backup. NVIDIA API Catalog is a hosted inference API, not Brev. The latest successful recording used Groq for all three coaching calls; NVIDIA was not exercised in that recording.</a:t>
             </a:r>
           </a:p>
         </p:txBody>
@@ -789,7 +789,7 @@
           <a:lstStyle/>
           <a:p>
             <a:r>
-              <a:t>These phone panels are code-native illustrations, not screenshots. The new public mobile flow passed at 390 by 844 with real Groq output, no horizontal overflow and no JavaScript errors. The flow covers consent, CV strengths, historical market priorities, a seven-day plan, an interview question and a downloadable HTML brief. The real sample returned 39.6% demand-weighted coverage over 391 Kenya Data Analyst postings; this is not hiring probability. Desktop returned three rewrites; mobile returned an honest empty rewrite list. No app install is required.</a:t>
+              <a:t>These phone panels are code-native illustrations, not screenshots; the posting, match figure and feedback score are examples. Panel one: after the CV, role and consent, Njia asks follow-up questions with four options, Used it at work, Used it in a project or course, Still learning it, or Not yet, plus one free-text outcome question. Panel two: live jobs open to the learner's country or worldwide, each with a skill-match percentage, meaning the share of skills detected in the posting that the learner has, plus matched and missing skills and a link to apply on the source. It is not a hiring probability. Panel three: an interview question that candidates report on the web, with its source link. The learner types an answer under separate consent and gets a 1–5 score, a STAR checklist, strengths, improvements and a stronger outline with placeholders instead of invented facts; if the provider fails, a labelled deterministic checklist is shown. The seven-day checklist can also be sent to WhatsApp. The earlier release passed public desktop and 390 by 844 mobile-browser checks; its tested brief returned 39.6% demand-weighted coverage over 391 Kenya Data Analyst postings. In the public recording on 27 Sep 2026, 8 remote Data Analyst cards and 3 local cards were rendered for Kenya. These are rendered card counts, not the source API total.</a:t>
             </a:r>
           </a:p>
         </p:txBody>
@@ -859,7 +859,7 @@
           <a:lstStyle/>
           <a:p>
             <a:r>
-              <a:t>Main implementation owner confirms 73 passing backend unit-test methods. Separately, coach-acceptance-results.json records 48 passing public acceptance assertions and njia-coach-demo-results.json records nine passing recording assertions, totaling 57 new public assertions. No mocked responses. Desktop, mobile and recording used Groq openai/gpt-oss-20b. Observed elapsed times were 2.259 seconds desktop, 1.318 mobile and 2.260 recording including PDF processing; these are individual observations, not a latency benchmark. All three runs recorded no JavaScript errors and all observed API responses succeeded. The sample used 391 Kenya Data Analyst postings and returned 39.6% demand-weighted coverage, not hiring odds. Recording is exactly 90 seconds at normal speed. Semantic factuality is not guaranteed: the recorded rewrite added unsupported real-time sales monitoring, despite number/tool checks. Human review is required. No real-user adoption or employment impact is claimed.</a:t>
+              <a:t>Main implementation owner confirms 126 passing backend unit-test methods. Separately, 48 public acceptance assertions and 9 recording assertions passed, totaling 57 public assertions. No mocked responses. Desktop, mobile and recording used Groq openai/gpt-oss-20b. Observed elapsed times were 2.259s desktop, 1.318s mobile and 2.260s recording including PDF processing; these are individual observations, not a latency benchmark. The runs recorded 0 JavaScript errors. The sample used 391 Kenya Data Analyst postings and returned 39.6% demand-weighted coverage, not hiring odds. New today: 8 remote + 3 local job cards shown; 8 source-linked interview questions; 19 new recording checks passed. Skill-match percentages measure skill overlap and are not a hiring probability. Semantic factuality is not guaranteed: the recorded rewrite added unsupported real-time sales monitoring, despite number/tool checks, and rewrites that use the learner's answers are labelled for verification. Human review is required. No real-user adoption or employment impact is claimed. Latest public recording: 19 recording assertions passed, separate from the earlier 57 public assertions. Groq openai/gpt-oss-20b: PDF plus follow-ups 1.271s, brief 1.450s, feedback 0.844s. Eight remote and three local job cards; eight web-sourced interview questions; feedback score 4/5. Exactly 90 seconds, 1x, silent captions; no late cues, no JavaScript errors, no mocked responses. The new rewrite added unsupported inventory decisions to a personal synthetic-data dashboard; human factual review is still required. NVIDIA was configured as backup, not used in this recording.</a:t>
             </a:r>
           </a:p>
         </p:txBody>
@@ -929,7 +929,7 @@
           <a:lstStyle/>
           <a:p>
             <a:r>
-              <a:t>This is a proposed pilot, not adoption or a signed partnership. We propose recruiting ten Kenyan learners with one training partner, reviewing outputs with a facilitator and following up after seven days. Measure completion, factual rewrite acceptance, saved practice artifacts, usefulness and mobile friction; do not present target outcomes as achieved. Click Mobile fit is the practical mobile-first Kenyan learner journey, with Dhruzzz participating as Kenya ONLINE. Published Kenya-only scope aligns with the team context; final award eligibility is determined by organizers. Brightest fits skills and employability, and Artefact fits visible use of local data and AI. No award win or organizer endorsement is claimed.</a:t>
+              <a:t>This is a proposed pilot, not adoption or a signed partnership. We propose recruiting ten Kenyan learners with one training partner, reviewing outputs with a facilitator and following up after seven days. Measure completion, factual rewrite acceptance, whether follow-up answers were reflected, relevance of the live jobs shown, usefulness of answer feedback, saved practice artifacts and mobile friction; do not present target outcomes as achieved. Click Mobile fit is the practical mobile-first Kenyan learner journey, with Dhruzzz participating as Kenya ONLINE. Published Kenya-only scope aligns with the team context; final award eligibility is determined by organizers. Brightest fits skills and employability, and Artefact fits visible use of local data and AI. No award win or organizer endorsement is claimed.</a:t>
             </a:r>
           </a:p>
         </p:txBody>
@@ -999,7 +999,7 @@
           <a:lstStyle/>
           <a:p>
             <a:r>
-              <a:t>Close with the live product and source repository. Team: Eeshan Vaghjiani, Bhavin Mepani and Dhruvin Bhudia; Kenya ONLINE. The new recorded production demo is verified locally at exactly 90 seconds, normal speed, with captions. Slide 8 links to the published demo-v1 release asset: https://github.com/Eeshan-Vaghjiani/njia/releases/download/demo-v1/njia-demo-90s.webm. Ask for a Kenyan learner or training partner to run the proposed pilot.</a:t>
+              <a:t>Close with the live product and source repository. Team: Eeshan Vaghjiani, Bhavin Mepani and Dhruvin Bhudia; Kenya ONLINE. Our line: Ask. Match. Practise. Your next move. The published demo-v1 recording is exactly 90 seconds, normal speed, with captions. Slide 8 links to it: https://github.com/Eeshan-Vaghjiani/njia/releases/download/demo-v1/njia-demo-90s.mp4. Ask for a Kenyan learner or training partner to run the proposed pilot.</a:t>
             </a:r>
           </a:p>
         </p:txBody>
@@ -4310,7 +4310,7 @@
         <p:spPr>
           <a:xfrm>
             <a:off x="694944" y="2697480"/>
-            <a:ext cx="8412480" cy="960120"/>
+            <a:ext cx="8595360" cy="960120"/>
           </a:xfrm>
           <a:prstGeom prst="rect">
             <a:avLst/>
@@ -4341,7 +4341,7 @@
                 </a:solidFill>
                 <a:latin typeface="Segoe UI"/>
               </a:rPr>
-              <a:t>AI career guidance grounded in your CV</a:t>
+              <a:t>A career coach that asks before it advises,</a:t>
             </a:r>
           </a:p>
           <a:p>
@@ -4363,7 +4363,7 @@
                 </a:solidFill>
                 <a:latin typeface="Segoe UI"/>
               </a:rPr>
-              <a:t>and the skills your target market asks for.</a:t>
+              <a:t>then matches you to jobs you can apply for.</a:t>
             </a:r>
           </a:p>
         </p:txBody>
@@ -4512,7 +4512,7 @@
         <p:spPr>
           <a:xfrm>
             <a:off x="1353312" y="5120640"/>
-            <a:ext cx="7315200" cy="356616"/>
+            <a:ext cx="7863840" cy="356616"/>
           </a:xfrm>
           <a:prstGeom prst="rect">
             <a:avLst/>
@@ -4543,7 +4543,7 @@
                 </a:solidFill>
                 <a:latin typeface="Segoe UI"/>
               </a:rPr>
-              <a:t>Find strengths backed by actual CV excerpts.</a:t>
+              <a:t>Njia asks follow-ups, then links strengths to CV evidence.</a:t>
             </a:r>
           </a:p>
         </p:txBody>
@@ -4633,7 +4633,7 @@
                 </a:solidFill>
                 <a:latin typeface="Segoe UI"/>
               </a:rPr>
-              <a:t>What should I work on first?</a:t>
+              <a:t>Which jobs can I apply for now?</a:t>
             </a:r>
           </a:p>
         </p:txBody>
@@ -4647,7 +4647,7 @@
         <p:spPr>
           <a:xfrm>
             <a:off x="1353312" y="5980176"/>
-            <a:ext cx="7315200" cy="356616"/>
+            <a:ext cx="7863840" cy="356616"/>
           </a:xfrm>
           <a:prstGeom prst="rect">
             <a:avLst/>
@@ -4678,7 +4678,7 @@
                 </a:solidFill>
                 <a:latin typeface="Segoe UI"/>
               </a:rPr>
-              <a:t>Prioritize skills using Kenya + target-role data.</a:t>
+              <a:t>Live postings with a skill-match %, not hiring odds.</a:t>
             </a:r>
           </a:p>
         </p:txBody>
@@ -4768,7 +4768,7 @@
                 </a:solidFill>
                 <a:latin typeface="Segoe UI"/>
               </a:rPr>
-              <a:t>What can I do this week?</a:t>
+              <a:t>Am I ready for the interview?</a:t>
             </a:r>
           </a:p>
         </p:txBody>
@@ -4782,7 +4782,7 @@
         <p:spPr>
           <a:xfrm>
             <a:off x="1353312" y="6839712"/>
-            <a:ext cx="7315200" cy="356616"/>
+            <a:ext cx="7863840" cy="356616"/>
           </a:xfrm>
           <a:prstGeom prst="rect">
             <a:avLst/>
@@ -4813,7 +4813,7 @@
                 </a:solidFill>
                 <a:latin typeface="Segoe UI"/>
               </a:rPr>
-              <a:t>Leave with clearer CV bullets and concrete practice.</a:t>
+              <a:t>Real reported questions, typed practice and AI feedback.</a:t>
             </a:r>
           </a:p>
         </p:txBody>
@@ -5082,7 +5082,7 @@
                 </a:solidFill>
                 <a:latin typeface="Segoe UI"/>
               </a:rPr>
-              <a:t>Needs a credible CV and</a:t>
+              <a:t>Unsure which roles fit</a:t>
             </a:r>
           </a:p>
           <a:p>
@@ -5104,7 +5104,7 @@
                 </a:solidFill>
                 <a:latin typeface="Segoe UI"/>
               </a:rPr>
-              <a:t>a focused learning plan.</a:t>
+              <a:t>and how to prepare.</a:t>
             </a:r>
           </a:p>
         </p:txBody>
@@ -5218,7 +5218,7 @@
                 </a:solidFill>
                 <a:latin typeface="Segoe UI"/>
               </a:rPr>
-              <a:t>02  /  THE PRODUCT UPGRADE</a:t>
+              <a:t>02  /  THE PRODUCT STORY</a:t>
             </a:r>
           </a:p>
         </p:txBody>
@@ -5263,7 +5263,7 @@
                 </a:solidFill>
                 <a:latin typeface="Georgia"/>
               </a:rPr>
-              <a:t>From a vague bullet to a useful next move.</a:t>
+              <a:t>Ask first. Then match and practise.</a:t>
             </a:r>
           </a:p>
         </p:txBody>
@@ -5308,7 +5308,7 @@
                 </a:solidFill>
                 <a:latin typeface="Segoe UI"/>
               </a:rPr>
-              <a:t>One assessment: evidence-grounded strengths, demand priorities, suggested rewrites and interview practice.</a:t>
+              <a:t>Follow-up questions, an evidence-linked brief, live job matches and interview practice.</a:t>
             </a:r>
           </a:p>
         </p:txBody>
@@ -5576,7 +5576,7 @@
                 </a:solidFill>
                 <a:latin typeface="Segoe UI"/>
               </a:rPr>
-              <a:t>BEFORE / SUPPLIED CV FACTS</a:t>
+              <a:t>BEFORE / CV LINE + YOUR ANSWER</a:t>
             </a:r>
           </a:p>
         </p:txBody>
@@ -5589,33 +5589,33 @@
         </p:nvSpPr>
         <p:spPr>
           <a:xfrm>
-            <a:off x="950976" y="4123944"/>
-            <a:ext cx="5303520" cy="1033271"/>
-          </a:xfrm>
-          <a:prstGeom prst="rect">
-            <a:avLst/>
-          </a:prstGeom>
-          <a:noFill/>
-        </p:spPr>
-        <p:txBody>
-          <a:bodyPr wrap="square" lIns="0" rIns="0" tIns="0" bIns="0">
-            <a:spAutoFit/>
-          </a:bodyPr>
-          <a:lstStyle/>
-          <a:p>
-            <a:pPr algn="l">
-              <a:lnSpc>
-                <a:spcPct val="112000"/>
-              </a:lnSpc>
-              <a:spcBef>
-                <a:spcPts val="0"/>
-              </a:spcBef>
-              <a:spcAft>
-                <a:spcPts val="0"/>
-              </a:spcAft>
-            </a:pPr>
-            <a:r>
-              <a:rPr sz="2664" b="0">
+            <a:off x="950976" y="4069080"/>
+            <a:ext cx="5303520" cy="768096"/>
+          </a:xfrm>
+          <a:prstGeom prst="rect">
+            <a:avLst/>
+          </a:prstGeom>
+          <a:noFill/>
+        </p:spPr>
+        <p:txBody>
+          <a:bodyPr wrap="square" lIns="0" rIns="0" tIns="0" bIns="0">
+            <a:spAutoFit/>
+          </a:bodyPr>
+          <a:lstStyle/>
+          <a:p>
+            <a:pPr algn="l">
+              <a:lnSpc>
+                <a:spcPct val="112000"/>
+              </a:lnSpc>
+              <a:spcBef>
+                <a:spcPts val="0"/>
+              </a:spcBef>
+              <a:spcAft>
+                <a:spcPts val="0"/>
+              </a:spcAft>
+            </a:pPr>
+            <a:r>
+              <a:rPr sz="2520" b="0">
                 <a:solidFill>
                   <a:srgbClr val="1B2D40"/>
                 </a:solidFill>
@@ -5637,7 +5637,7 @@
               </a:spcAft>
             </a:pPr>
             <a:r>
-              <a:rPr sz="2664" b="0">
+              <a:rPr sz="2520" b="0">
                 <a:solidFill>
                   <a:srgbClr val="1B2D40"/>
                 </a:solidFill>
@@ -5651,6 +5651,73 @@
       <p:sp>
         <p:nvSpPr>
           <p:cNvPr id="13" name="TextBox 12"/>
+          <p:cNvSpPr txBox="1"/>
+          <p:nvPr/>
+        </p:nvSpPr>
+        <p:spPr>
+          <a:xfrm>
+            <a:off x="950976" y="4946904"/>
+            <a:ext cx="5303520" cy="512064"/>
+          </a:xfrm>
+          <a:prstGeom prst="rect">
+            <a:avLst/>
+          </a:prstGeom>
+          <a:noFill/>
+        </p:spPr>
+        <p:txBody>
+          <a:bodyPr wrap="square" lIns="0" rIns="0" tIns="0" bIns="0">
+            <a:spAutoFit/>
+          </a:bodyPr>
+          <a:lstStyle/>
+          <a:p>
+            <a:pPr algn="l">
+              <a:lnSpc>
+                <a:spcPct val="112000"/>
+              </a:lnSpc>
+              <a:spcBef>
+                <a:spcPts val="0"/>
+              </a:spcBef>
+              <a:spcAft>
+                <a:spcPts val="0"/>
+              </a:spcAft>
+            </a:pPr>
+            <a:r>
+              <a:rPr sz="1584" b="0">
+                <a:solidFill>
+                  <a:srgbClr val="586777"/>
+                </a:solidFill>
+                <a:latin typeface="Segoe UI"/>
+              </a:rPr>
+              <a:t>Your answer: “Managers used them in</a:t>
+            </a:r>
+          </a:p>
+          <a:p>
+            <a:pPr algn="l">
+              <a:lnSpc>
+                <a:spcPct val="112000"/>
+              </a:lnSpc>
+              <a:spcBef>
+                <a:spcPts val="0"/>
+              </a:spcBef>
+              <a:spcAft>
+                <a:spcPts val="0"/>
+              </a:spcAft>
+            </a:pPr>
+            <a:r>
+              <a:rPr sz="1584" b="0">
+                <a:solidFill>
+                  <a:srgbClr val="586777"/>
+                </a:solidFill>
+                <a:latin typeface="Segoe UI"/>
+              </a:rPr>
+              <a:t>Monday stock reviews.”</a:t>
+            </a:r>
+          </a:p>
+        </p:txBody>
+      </p:sp>
+      <p:sp>
+        <p:nvSpPr>
+          <p:cNvPr id="14" name="TextBox 13"/>
           <p:cNvSpPr txBox="1"/>
           <p:nvPr/>
         </p:nvSpPr>
@@ -5688,81 +5755,148 @@
                 </a:solidFill>
                 <a:latin typeface="Segoe UI"/>
               </a:rPr>
-              <a:t>AFTER / HUMAN-REVIEWED EXAMPLE</a:t>
-            </a:r>
-          </a:p>
-        </p:txBody>
-      </p:sp>
-      <p:sp>
-        <p:nvSpPr>
-          <p:cNvPr id="14" name="TextBox 13"/>
-          <p:cNvSpPr txBox="1"/>
-          <p:nvPr/>
-        </p:nvSpPr>
-        <p:spPr>
-          <a:xfrm>
-            <a:off x="7388352" y="4123944"/>
-            <a:ext cx="6190488" cy="1033271"/>
-          </a:xfrm>
-          <a:prstGeom prst="rect">
-            <a:avLst/>
-          </a:prstGeom>
-          <a:noFill/>
-        </p:spPr>
-        <p:txBody>
-          <a:bodyPr wrap="square" lIns="0" rIns="0" tIns="0" bIns="0">
-            <a:spAutoFit/>
-          </a:bodyPr>
-          <a:lstStyle/>
-          <a:p>
-            <a:pPr algn="l">
-              <a:lnSpc>
-                <a:spcPct val="112000"/>
-              </a:lnSpc>
-              <a:spcBef>
-                <a:spcPts val="0"/>
-              </a:spcBef>
-              <a:spcAft>
-                <a:spcPts val="0"/>
-              </a:spcAft>
-            </a:pPr>
-            <a:r>
-              <a:rPr sz="2592" b="0">
+              <a:t>AFTER / USES YOUR ANSWER — VERIFY</a:t>
+            </a:r>
+          </a:p>
+        </p:txBody>
+      </p:sp>
+      <p:sp>
+        <p:nvSpPr>
+          <p:cNvPr id="15" name="TextBox 14"/>
+          <p:cNvSpPr txBox="1"/>
+          <p:nvPr/>
+        </p:nvSpPr>
+        <p:spPr>
+          <a:xfrm>
+            <a:off x="7388352" y="4069080"/>
+            <a:ext cx="6309360" cy="1143000"/>
+          </a:xfrm>
+          <a:prstGeom prst="rect">
+            <a:avLst/>
+          </a:prstGeom>
+          <a:noFill/>
+        </p:spPr>
+        <p:txBody>
+          <a:bodyPr wrap="square" lIns="0" rIns="0" tIns="0" bIns="0">
+            <a:spAutoFit/>
+          </a:bodyPr>
+          <a:lstStyle/>
+          <a:p>
+            <a:pPr algn="l">
+              <a:lnSpc>
+                <a:spcPct val="112000"/>
+              </a:lnSpc>
+              <a:spcBef>
+                <a:spcPts val="0"/>
+              </a:spcBef>
+              <a:spcAft>
+                <a:spcPts val="0"/>
+              </a:spcAft>
+            </a:pPr>
+            <a:r>
+              <a:rPr sz="2520" b="0">
                 <a:solidFill>
                   <a:srgbClr val="F7F4EC"/>
                 </a:solidFill>
                 <a:latin typeface="Georgia"/>
               </a:rPr>
-              <a:t>“Prepared weekly sales charts in Excel</a:t>
-            </a:r>
-          </a:p>
-          <a:p>
-            <a:pPr algn="l">
-              <a:lnSpc>
-                <a:spcPct val="112000"/>
-              </a:lnSpc>
-              <a:spcBef>
-                <a:spcPts val="0"/>
-              </a:spcBef>
-              <a:spcAft>
-                <a:spcPts val="0"/>
-              </a:spcAft>
-            </a:pPr>
-            <a:r>
-              <a:rPr sz="2592" b="0">
+              <a:t>“Prepared weekly Excel sales charts</a:t>
+            </a:r>
+          </a:p>
+          <a:p>
+            <a:pPr algn="l">
+              <a:lnSpc>
+                <a:spcPct val="112000"/>
+              </a:lnSpc>
+              <a:spcBef>
+                <a:spcPts val="0"/>
+              </a:spcBef>
+              <a:spcAft>
+                <a:spcPts val="0"/>
+              </a:spcAft>
+            </a:pPr>
+            <a:r>
+              <a:rPr sz="2520" b="0">
                 <a:solidFill>
                   <a:srgbClr val="F7F4EC"/>
                 </a:solidFill>
                 <a:latin typeface="Georgia"/>
               </a:rPr>
-              <a:t>using cleaned sales data.”</a:t>
-            </a:r>
-          </a:p>
-        </p:txBody>
-      </p:sp>
-      <p:sp>
-        <p:nvSpPr>
-          <p:cNvPr id="15" name="Rectangle 14"/>
+              <a:t>from cleaned data for managers’</a:t>
+            </a:r>
+          </a:p>
+          <a:p>
+            <a:pPr algn="l">
+              <a:lnSpc>
+                <a:spcPct val="112000"/>
+              </a:lnSpc>
+              <a:spcBef>
+                <a:spcPts val="0"/>
+              </a:spcBef>
+              <a:spcAft>
+                <a:spcPts val="0"/>
+              </a:spcAft>
+            </a:pPr>
+            <a:r>
+              <a:rPr sz="2520" b="0">
+                <a:solidFill>
+                  <a:srgbClr val="F7F4EC"/>
+                </a:solidFill>
+                <a:latin typeface="Georgia"/>
+              </a:rPr>
+              <a:t>Monday stock reviews.”</a:t>
+            </a:r>
+          </a:p>
+        </p:txBody>
+      </p:sp>
+      <p:sp>
+        <p:nvSpPr>
+          <p:cNvPr id="16" name="TextBox 15"/>
+          <p:cNvSpPr txBox="1"/>
+          <p:nvPr/>
+        </p:nvSpPr>
+        <p:spPr>
+          <a:xfrm>
+            <a:off x="7388352" y="5276088"/>
+            <a:ext cx="6309360" cy="237744"/>
+          </a:xfrm>
+          <a:prstGeom prst="rect">
+            <a:avLst/>
+          </a:prstGeom>
+          <a:noFill/>
+        </p:spPr>
+        <p:txBody>
+          <a:bodyPr wrap="square" lIns="0" rIns="0" tIns="0" bIns="0">
+            <a:spAutoFit/>
+          </a:bodyPr>
+          <a:lstStyle/>
+          <a:p>
+            <a:pPr algn="l">
+              <a:lnSpc>
+                <a:spcPct val="112000"/>
+              </a:lnSpc>
+              <a:spcBef>
+                <a:spcPts val="0"/>
+              </a:spcBef>
+              <a:spcAft>
+                <a:spcPts val="0"/>
+              </a:spcAft>
+            </a:pPr>
+            <a:r>
+              <a:rPr sz="1368" b="0">
+                <a:solidFill>
+                  <a:srgbClr val="D4DEE6"/>
+                </a:solidFill>
+                <a:latin typeface="Segoe UI"/>
+              </a:rPr>
+              <a:t>Same facts plus the learner's own answer. Nothing invented.</a:t>
+            </a:r>
+          </a:p>
+        </p:txBody>
+      </p:sp>
+      <p:sp>
+        <p:nvSpPr>
+          <p:cNvPr id="17" name="Rectangle 16"/>
           <p:cNvSpPr/>
           <p:nvPr/>
         </p:nvSpPr>
@@ -5805,7 +5939,7 @@
       </p:sp>
       <p:sp>
         <p:nvSpPr>
-          <p:cNvPr id="16" name="TextBox 15"/>
+          <p:cNvPr id="18" name="TextBox 17"/>
           <p:cNvSpPr txBox="1"/>
           <p:nvPr/>
         </p:nvSpPr>
@@ -5843,21 +5977,21 @@
                 </a:solidFill>
                 <a:latin typeface="Segoe UI"/>
               </a:rPr>
-              <a:t>01 / Strength</a:t>
-            </a:r>
-          </a:p>
-        </p:txBody>
-      </p:sp>
-      <p:sp>
-        <p:nvSpPr>
-          <p:cNvPr id="17" name="TextBox 16"/>
+              <a:t>01 / Ask</a:t>
+            </a:r>
+          </a:p>
+        </p:txBody>
+      </p:sp>
+      <p:sp>
+        <p:nvSpPr>
+          <p:cNvPr id="19" name="TextBox 18"/>
           <p:cNvSpPr txBox="1"/>
           <p:nvPr/>
         </p:nvSpPr>
         <p:spPr>
           <a:xfrm>
             <a:off x="676656" y="6693408"/>
-            <a:ext cx="4160520" cy="658368"/>
+            <a:ext cx="4206240" cy="658368"/>
           </a:xfrm>
           <a:prstGeom prst="rect">
             <a:avLst/>
@@ -5888,7 +6022,7 @@
                 </a:solidFill>
                 <a:latin typeface="Segoe UI"/>
               </a:rPr>
-              <a:t>Excel data preparation, supported</a:t>
+              <a:t>Skill + outcome follow-ups</a:t>
             </a:r>
           </a:p>
           <a:p>
@@ -5910,14 +6044,14 @@
                 </a:solidFill>
                 <a:latin typeface="Segoe UI"/>
               </a:rPr>
-              <a:t>by the learner's own CV excerpt.</a:t>
-            </a:r>
-          </a:p>
-        </p:txBody>
-      </p:sp>
-      <p:sp>
-        <p:nvSpPr>
-          <p:cNvPr id="18" name="Rectangle 17"/>
+              <a:t>reshape skills and the brief.</a:t>
+            </a:r>
+          </a:p>
+        </p:txBody>
+      </p:sp>
+      <p:sp>
+        <p:nvSpPr>
+          <p:cNvPr id="20" name="Rectangle 19"/>
           <p:cNvSpPr/>
           <p:nvPr/>
         </p:nvSpPr>
@@ -5960,7 +6094,7 @@
       </p:sp>
       <p:sp>
         <p:nvSpPr>
-          <p:cNvPr id="19" name="TextBox 18"/>
+          <p:cNvPr id="21" name="TextBox 20"/>
           <p:cNvSpPr txBox="1"/>
           <p:nvPr/>
         </p:nvSpPr>
@@ -5998,21 +6132,21 @@
                 </a:solidFill>
                 <a:latin typeface="Segoe UI"/>
               </a:rPr>
-              <a:t>02 / Priority</a:t>
-            </a:r>
-          </a:p>
-        </p:txBody>
-      </p:sp>
-      <p:sp>
-        <p:nvSpPr>
-          <p:cNvPr id="20" name="TextBox 19"/>
+              <a:t>02 / Match</a:t>
+            </a:r>
+          </a:p>
+        </p:txBody>
+      </p:sp>
+      <p:sp>
+        <p:nvSpPr>
+          <p:cNvPr id="22" name="TextBox 21"/>
           <p:cNvSpPr txBox="1"/>
           <p:nvPr/>
         </p:nvSpPr>
         <p:spPr>
           <a:xfrm>
             <a:off x="5221224" y="6693408"/>
-            <a:ext cx="4160520" cy="658368"/>
+            <a:ext cx="4206240" cy="658368"/>
           </a:xfrm>
           <a:prstGeom prst="rect">
             <a:avLst/>
@@ -6043,7 +6177,7 @@
                 </a:solidFill>
                 <a:latin typeface="Segoe UI"/>
               </a:rPr>
-              <a:t>If SQL is not evidenced, start with</a:t>
+              <a:t>Live jobs you can apply for,</a:t>
             </a:r>
           </a:p>
           <a:p>
@@ -6065,14 +6199,14 @@
                 </a:solidFill>
                 <a:latin typeface="Segoe UI"/>
               </a:rPr>
-              <a:t>a JOIN and a checked summary.</a:t>
-            </a:r>
-          </a:p>
-        </p:txBody>
-      </p:sp>
-      <p:sp>
-        <p:nvSpPr>
-          <p:cNvPr id="21" name="Rectangle 20"/>
+              <a:t>with matched + missing skills.</a:t>
+            </a:r>
+          </a:p>
+        </p:txBody>
+      </p:sp>
+      <p:sp>
+        <p:nvSpPr>
+          <p:cNvPr id="23" name="Rectangle 22"/>
           <p:cNvSpPr/>
           <p:nvPr/>
         </p:nvSpPr>
@@ -6115,7 +6249,7 @@
       </p:sp>
       <p:sp>
         <p:nvSpPr>
-          <p:cNvPr id="22" name="TextBox 21"/>
+          <p:cNvPr id="24" name="TextBox 23"/>
           <p:cNvSpPr txBox="1"/>
           <p:nvPr/>
         </p:nvSpPr>
@@ -6153,21 +6287,21 @@
                 </a:solidFill>
                 <a:latin typeface="Segoe UI"/>
               </a:rPr>
-              <a:t>03 / Action</a:t>
-            </a:r>
-          </a:p>
-        </p:txBody>
-      </p:sp>
-      <p:sp>
-        <p:nvSpPr>
-          <p:cNvPr id="23" name="TextBox 22"/>
+              <a:t>03 / Practise</a:t>
+            </a:r>
+          </a:p>
+        </p:txBody>
+      </p:sp>
+      <p:sp>
+        <p:nvSpPr>
+          <p:cNvPr id="25" name="TextBox 24"/>
           <p:cNvSpPr txBox="1"/>
           <p:nvPr/>
         </p:nvSpPr>
         <p:spPr>
           <a:xfrm>
             <a:off x="9765792" y="6693408"/>
-            <a:ext cx="4160520" cy="658368"/>
+            <a:ext cx="4206240" cy="658368"/>
           </a:xfrm>
           <a:prstGeom prst="rect">
             <a:avLst/>
@@ -6198,7 +6332,7 @@
                 </a:solidFill>
                 <a:latin typeface="Segoe UI"/>
               </a:rPr>
-              <a:t>A seven-day plan plus a tailored</a:t>
+              <a:t>Sourced questions + AI feedback;</a:t>
             </a:r>
           </a:p>
           <a:p>
@@ -6220,14 +6354,14 @@
                 </a:solidFill>
                 <a:latin typeface="Segoe UI"/>
               </a:rPr>
-              <a:t>interview question and rubric.</a:t>
-            </a:r>
-          </a:p>
-        </p:txBody>
-      </p:sp>
-      <p:sp>
-        <p:nvSpPr>
-          <p:cNvPr id="24" name="TextBox 23"/>
+              <a:t>send the 7-day plan to WhatsApp.</a:t>
+            </a:r>
+          </a:p>
+        </p:txBody>
+      </p:sp>
+      <p:sp>
+        <p:nvSpPr>
+          <p:cNvPr id="26" name="TextBox 25"/>
           <p:cNvSpPr txBox="1"/>
           <p:nvPr/>
         </p:nvSpPr>
@@ -6265,7 +6399,7 @@
                 </a:solidFill>
                 <a:latin typeface="Segoe UI"/>
               </a:rPr>
-              <a:t>CV rewrites checked for numbers/tools, still require human factual review. Example below is illustrative.</a:t>
+              <a:t>Illustrative, hand-authored example. Rewrites are checked for numbers/tools and still need human factual review.</a:t>
             </a:r>
           </a:p>
         </p:txBody>
@@ -7921,7 +8055,7 @@
         <p:spPr>
           <a:xfrm>
             <a:off x="9299448" y="5971032"/>
-            <a:ext cx="4361688" cy="850392"/>
+            <a:ext cx="4480560" cy="850392"/>
           </a:xfrm>
           <a:prstGeom prst="rect">
             <a:avLst/>
@@ -7952,7 +8086,7 @@
                 </a:solidFill>
                 <a:latin typeface="Segoe UI"/>
               </a:rPr>
-              <a:t>Share of sampled posts mentioning each skill.</a:t>
+              <a:t>Share of sampled posts naming each skill.</a:t>
             </a:r>
           </a:p>
           <a:p>
@@ -7974,7 +8108,7 @@
                 </a:solidFill>
                 <a:latin typeface="Segoe UI"/>
               </a:rPr>
-              <a:t>Multiple skills can appear in one posting.</a:t>
+              <a:t>One post can mention several skills.</a:t>
             </a:r>
           </a:p>
           <a:p>
@@ -8246,7 +8380,7 @@
                 </a:solidFill>
                 <a:latin typeface="Segoe UI"/>
               </a:rPr>
-              <a:t>AI interprets experience and writes tailored guidance; deterministic code supplies the market evidence.</a:t>
+              <a:t>AI asks and coaches; code computes market figures and keeps only source-verified web results.</a:t>
             </a:r>
           </a:p>
         </p:txBody>
@@ -8437,33 +8571,33 @@
         </p:nvSpPr>
         <p:spPr>
           <a:xfrm>
-            <a:off x="923544" y="3675887"/>
-            <a:ext cx="2606040" cy="585216"/>
-          </a:xfrm>
-          <a:prstGeom prst="rect">
-            <a:avLst/>
-          </a:prstGeom>
-          <a:noFill/>
-        </p:spPr>
-        <p:txBody>
-          <a:bodyPr wrap="square" lIns="0" rIns="0" tIns="0" bIns="0">
-            <a:spAutoFit/>
-          </a:bodyPr>
-          <a:lstStyle/>
-          <a:p>
-            <a:pPr algn="l">
-              <a:lnSpc>
-                <a:spcPct val="112000"/>
-              </a:lnSpc>
-              <a:spcBef>
-                <a:spcPts val="0"/>
-              </a:spcBef>
-              <a:spcAft>
-                <a:spcPts val="0"/>
-              </a:spcAft>
-            </a:pPr>
-            <a:r>
-              <a:rPr sz="3168" b="1">
+            <a:off x="923544" y="3621024"/>
+            <a:ext cx="2606040" cy="512064"/>
+          </a:xfrm>
+          <a:prstGeom prst="rect">
+            <a:avLst/>
+          </a:prstGeom>
+          <a:noFill/>
+        </p:spPr>
+        <p:txBody>
+          <a:bodyPr wrap="square" lIns="0" rIns="0" tIns="0" bIns="0">
+            <a:spAutoFit/>
+          </a:bodyPr>
+          <a:lstStyle/>
+          <a:p>
+            <a:pPr algn="l">
+              <a:lnSpc>
+                <a:spcPct val="112000"/>
+              </a:lnSpc>
+              <a:spcBef>
+                <a:spcPts val="0"/>
+              </a:spcBef>
+              <a:spcAft>
+                <a:spcPts val="0"/>
+              </a:spcAft>
+            </a:pPr>
+            <a:r>
+              <a:rPr sz="2879" b="1">
                 <a:solidFill>
                   <a:srgbClr val="F27B43"/>
                 </a:solidFill>
@@ -8482,39 +8616,39 @@
         </p:nvSpPr>
         <p:spPr>
           <a:xfrm>
-            <a:off x="923544" y="4361688"/>
-            <a:ext cx="2688336" cy="411480"/>
-          </a:xfrm>
-          <a:prstGeom prst="rect">
-            <a:avLst/>
-          </a:prstGeom>
-          <a:noFill/>
-        </p:spPr>
-        <p:txBody>
-          <a:bodyPr wrap="square" lIns="0" rIns="0" tIns="0" bIns="0">
-            <a:spAutoFit/>
-          </a:bodyPr>
-          <a:lstStyle/>
-          <a:p>
-            <a:pPr algn="l">
-              <a:lnSpc>
-                <a:spcPct val="112000"/>
-              </a:lnSpc>
-              <a:spcBef>
-                <a:spcPts val="0"/>
-              </a:spcBef>
-              <a:spcAft>
-                <a:spcPts val="0"/>
-              </a:spcAft>
-            </a:pPr>
-            <a:r>
-              <a:rPr sz="2232" b="1">
+            <a:off x="923544" y="4187952"/>
+            <a:ext cx="2688336" cy="384048"/>
+          </a:xfrm>
+          <a:prstGeom prst="rect">
+            <a:avLst/>
+          </a:prstGeom>
+          <a:noFill/>
+        </p:spPr>
+        <p:txBody>
+          <a:bodyPr wrap="square" lIns="0" rIns="0" tIns="0" bIns="0">
+            <a:spAutoFit/>
+          </a:bodyPr>
+          <a:lstStyle/>
+          <a:p>
+            <a:pPr algn="l">
+              <a:lnSpc>
+                <a:spcPct val="112000"/>
+              </a:lnSpc>
+              <a:spcBef>
+                <a:spcPts val="0"/>
+              </a:spcBef>
+              <a:spcAft>
+                <a:spcPts val="0"/>
+              </a:spcAft>
+            </a:pPr>
+            <a:r>
+              <a:rPr sz="2160" b="1">
                 <a:solidFill>
                   <a:srgbClr val="F7F4EC"/>
                 </a:solidFill>
                 <a:latin typeface="Segoe UI"/>
               </a:rPr>
-              <a:t>CV + consent</a:t>
+              <a:t>CV + answers</a:t>
             </a:r>
           </a:p>
         </p:txBody>
@@ -8527,38 +8661,60 @@
         </p:nvSpPr>
         <p:spPr>
           <a:xfrm>
-            <a:off x="923544" y="4892040"/>
-            <a:ext cx="2715768" cy="932688"/>
-          </a:xfrm>
-          <a:prstGeom prst="rect">
-            <a:avLst/>
-          </a:prstGeom>
-          <a:noFill/>
-        </p:spPr>
-        <p:txBody>
-          <a:bodyPr wrap="square" lIns="0" rIns="0" tIns="0" bIns="0">
-            <a:spAutoFit/>
-          </a:bodyPr>
-          <a:lstStyle/>
-          <a:p>
-            <a:pPr algn="l">
-              <a:lnSpc>
-                <a:spcPct val="112000"/>
-              </a:lnSpc>
-              <a:spcBef>
-                <a:spcPts val="0"/>
-              </a:spcBef>
-              <a:spcAft>
-                <a:spcPts val="0"/>
-              </a:spcAft>
-            </a:pPr>
-            <a:r>
-              <a:rPr sz="1655" b="0">
+            <a:off x="923544" y="4681728"/>
+            <a:ext cx="2788920" cy="1078992"/>
+          </a:xfrm>
+          <a:prstGeom prst="rect">
+            <a:avLst/>
+          </a:prstGeom>
+          <a:noFill/>
+        </p:spPr>
+        <p:txBody>
+          <a:bodyPr wrap="square" lIns="0" rIns="0" tIns="0" bIns="0">
+            <a:spAutoFit/>
+          </a:bodyPr>
+          <a:lstStyle/>
+          <a:p>
+            <a:pPr algn="l">
+              <a:lnSpc>
+                <a:spcPct val="112000"/>
+              </a:lnSpc>
+              <a:spcBef>
+                <a:spcPts val="0"/>
+              </a:spcBef>
+              <a:spcAft>
+                <a:spcPts val="0"/>
+              </a:spcAft>
+            </a:pPr>
+            <a:r>
+              <a:rPr sz="1584" b="0">
                 <a:solidFill>
                   <a:srgbClr val="D4DEE6"/>
                 </a:solidFill>
                 <a:latin typeface="Segoe UI"/>
               </a:rPr>
+              <a:t>Opt-in + PII redaction</a:t>
+            </a:r>
+          </a:p>
+          <a:p>
+            <a:pPr algn="l">
+              <a:lnSpc>
+                <a:spcPct val="112000"/>
+              </a:lnSpc>
+              <a:spcBef>
+                <a:spcPts val="0"/>
+              </a:spcBef>
+              <a:spcAft>
+                <a:spcPts val="0"/>
+              </a:spcAft>
+            </a:pPr>
+            <a:r>
+              <a:rPr sz="1584" b="0">
+                <a:solidFill>
+                  <a:srgbClr val="D4DEE6"/>
+                </a:solidFill>
+                <a:latin typeface="Segoe UI"/>
+              </a:rPr>
               <a:t>Country + target role</a:t>
             </a:r>
           </a:p>
@@ -8575,35 +8731,35 @@
               </a:spcAft>
             </a:pPr>
             <a:r>
-              <a:rPr sz="1655" b="0">
+              <a:rPr sz="1584" b="0">
                 <a:solidFill>
                   <a:srgbClr val="D4DEE6"/>
                 </a:solidFill>
                 <a:latin typeface="Segoe UI"/>
               </a:rPr>
-              <a:t>Basic PII redaction</a:t>
-            </a:r>
-          </a:p>
-          <a:p>
-            <a:pPr algn="l">
-              <a:lnSpc>
-                <a:spcPct val="112000"/>
-              </a:lnSpc>
-              <a:spcBef>
-                <a:spcPts val="0"/>
-              </a:spcBef>
-              <a:spcAft>
-                <a:spcPts val="0"/>
-              </a:spcAft>
-            </a:pPr>
-            <a:r>
-              <a:rPr sz="1655" b="0">
+              <a:t>3–5 follow-up questions</a:t>
+            </a:r>
+          </a:p>
+          <a:p>
+            <a:pPr algn="l">
+              <a:lnSpc>
+                <a:spcPct val="112000"/>
+              </a:lnSpc>
+              <a:spcBef>
+                <a:spcPts val="0"/>
+              </a:spcBef>
+              <a:spcAft>
+                <a:spcPts val="0"/>
+              </a:spcAft>
+            </a:pPr>
+            <a:r>
+              <a:rPr sz="1584" b="0">
                 <a:solidFill>
                   <a:srgbClr val="D4DEE6"/>
                 </a:solidFill>
                 <a:latin typeface="Segoe UI"/>
               </a:rPr>
-              <a:t>Opt-in before AI transfer</a:t>
+              <a:t>Answers reshape skills</a:t>
             </a:r>
           </a:p>
         </p:txBody>
@@ -8616,7 +8772,7 @@
         </p:nvSpPr>
         <p:spPr>
           <a:xfrm>
-            <a:off x="3840480" y="4389120"/>
+            <a:off x="3840480" y="4206240"/>
             <a:ext cx="256032" cy="457200"/>
           </a:xfrm>
           <a:prstGeom prst="rect">
@@ -8706,33 +8862,33 @@
         </p:nvSpPr>
         <p:spPr>
           <a:xfrm>
-            <a:off x="4306824" y="3675887"/>
-            <a:ext cx="2606040" cy="585216"/>
-          </a:xfrm>
-          <a:prstGeom prst="rect">
-            <a:avLst/>
-          </a:prstGeom>
-          <a:noFill/>
-        </p:spPr>
-        <p:txBody>
-          <a:bodyPr wrap="square" lIns="0" rIns="0" tIns="0" bIns="0">
-            <a:spAutoFit/>
-          </a:bodyPr>
-          <a:lstStyle/>
-          <a:p>
-            <a:pPr algn="l">
-              <a:lnSpc>
-                <a:spcPct val="112000"/>
-              </a:lnSpc>
-              <a:spcBef>
-                <a:spcPts val="0"/>
-              </a:spcBef>
-              <a:spcAft>
-                <a:spcPts val="0"/>
-              </a:spcAft>
-            </a:pPr>
-            <a:r>
-              <a:rPr sz="3168" b="1">
+            <a:off x="4306824" y="3621024"/>
+            <a:ext cx="2606040" cy="512064"/>
+          </a:xfrm>
+          <a:prstGeom prst="rect">
+            <a:avLst/>
+          </a:prstGeom>
+          <a:noFill/>
+        </p:spPr>
+        <p:txBody>
+          <a:bodyPr wrap="square" lIns="0" rIns="0" tIns="0" bIns="0">
+            <a:spAutoFit/>
+          </a:bodyPr>
+          <a:lstStyle/>
+          <a:p>
+            <a:pPr algn="l">
+              <a:lnSpc>
+                <a:spcPct val="112000"/>
+              </a:lnSpc>
+              <a:spcBef>
+                <a:spcPts val="0"/>
+              </a:spcBef>
+              <a:spcAft>
+                <a:spcPts val="0"/>
+              </a:spcAft>
+            </a:pPr>
+            <a:r>
+              <a:rPr sz="2879" b="1">
                 <a:solidFill>
                   <a:srgbClr val="F27B43"/>
                 </a:solidFill>
@@ -8751,33 +8907,33 @@
         </p:nvSpPr>
         <p:spPr>
           <a:xfrm>
-            <a:off x="4306824" y="4361688"/>
-            <a:ext cx="2688336" cy="411480"/>
-          </a:xfrm>
-          <a:prstGeom prst="rect">
-            <a:avLst/>
-          </a:prstGeom>
-          <a:noFill/>
-        </p:spPr>
-        <p:txBody>
-          <a:bodyPr wrap="square" lIns="0" rIns="0" tIns="0" bIns="0">
-            <a:spAutoFit/>
-          </a:bodyPr>
-          <a:lstStyle/>
-          <a:p>
-            <a:pPr algn="l">
-              <a:lnSpc>
-                <a:spcPct val="112000"/>
-              </a:lnSpc>
-              <a:spcBef>
-                <a:spcPts val="0"/>
-              </a:spcBef>
-              <a:spcAft>
-                <a:spcPts val="0"/>
-              </a:spcAft>
-            </a:pPr>
-            <a:r>
-              <a:rPr sz="2232" b="1">
+            <a:off x="4306824" y="4187952"/>
+            <a:ext cx="2688336" cy="384048"/>
+          </a:xfrm>
+          <a:prstGeom prst="rect">
+            <a:avLst/>
+          </a:prstGeom>
+          <a:noFill/>
+        </p:spPr>
+        <p:txBody>
+          <a:bodyPr wrap="square" lIns="0" rIns="0" tIns="0" bIns="0">
+            <a:spAutoFit/>
+          </a:bodyPr>
+          <a:lstStyle/>
+          <a:p>
+            <a:pPr algn="l">
+              <a:lnSpc>
+                <a:spcPct val="112000"/>
+              </a:lnSpc>
+              <a:spcBef>
+                <a:spcPts val="0"/>
+              </a:spcBef>
+              <a:spcAft>
+                <a:spcPts val="0"/>
+              </a:spcAft>
+            </a:pPr>
+            <a:r>
+              <a:rPr sz="2160" b="1">
                 <a:solidFill>
                   <a:srgbClr val="F7F4EC"/>
                 </a:solidFill>
@@ -8796,60 +8952,82 @@
         </p:nvSpPr>
         <p:spPr>
           <a:xfrm>
-            <a:off x="4306824" y="4892040"/>
-            <a:ext cx="2715768" cy="932688"/>
-          </a:xfrm>
-          <a:prstGeom prst="rect">
-            <a:avLst/>
-          </a:prstGeom>
-          <a:noFill/>
-        </p:spPr>
-        <p:txBody>
-          <a:bodyPr wrap="square" lIns="0" rIns="0" tIns="0" bIns="0">
-            <a:spAutoFit/>
-          </a:bodyPr>
-          <a:lstStyle/>
-          <a:p>
-            <a:pPr algn="l">
-              <a:lnSpc>
-                <a:spcPct val="112000"/>
-              </a:lnSpc>
-              <a:spcBef>
-                <a:spcPts val="0"/>
-              </a:spcBef>
-              <a:spcAft>
-                <a:spcPts val="0"/>
-              </a:spcAft>
-            </a:pPr>
-            <a:r>
-              <a:rPr sz="1655" b="0">
+            <a:off x="4306824" y="4681728"/>
+            <a:ext cx="2788920" cy="1078992"/>
+          </a:xfrm>
+          <a:prstGeom prst="rect">
+            <a:avLst/>
+          </a:prstGeom>
+          <a:noFill/>
+        </p:spPr>
+        <p:txBody>
+          <a:bodyPr wrap="square" lIns="0" rIns="0" tIns="0" bIns="0">
+            <a:spAutoFit/>
+          </a:bodyPr>
+          <a:lstStyle/>
+          <a:p>
+            <a:pPr algn="l">
+              <a:lnSpc>
+                <a:spcPct val="112000"/>
+              </a:lnSpc>
+              <a:spcBef>
+                <a:spcPts val="0"/>
+              </a:spcBef>
+              <a:spcAft>
+                <a:spcPts val="0"/>
+              </a:spcAft>
+            </a:pPr>
+            <a:r>
+              <a:rPr sz="1584" b="0">
                 <a:solidFill>
                   <a:srgbClr val="D4DEE6"/>
                 </a:solidFill>
                 <a:latin typeface="Segoe UI"/>
               </a:rPr>
-              <a:t>CV evidence excerpts</a:t>
-            </a:r>
-          </a:p>
-          <a:p>
-            <a:pPr algn="l">
-              <a:lnSpc>
-                <a:spcPct val="112000"/>
-              </a:lnSpc>
-              <a:spcBef>
-                <a:spcPts val="0"/>
-              </a:spcBef>
-              <a:spcAft>
-                <a:spcPts val="0"/>
-              </a:spcAft>
-            </a:pPr>
-            <a:r>
-              <a:rPr sz="1655" b="0">
+              <a:t>CV + answer evidence</a:t>
+            </a:r>
+          </a:p>
+          <a:p>
+            <a:pPr algn="l">
+              <a:lnSpc>
+                <a:spcPct val="112000"/>
+              </a:lnSpc>
+              <a:spcBef>
+                <a:spcPts val="0"/>
+              </a:spcBef>
+              <a:spcAft>
+                <a:spcPts val="0"/>
+              </a:spcAft>
+            </a:pPr>
+            <a:r>
+              <a:rPr sz="1584" b="0">
                 <a:solidFill>
                   <a:srgbClr val="D4DEE6"/>
                 </a:solidFill>
                 <a:latin typeface="Segoe UI"/>
               </a:rPr>
+              <a:t>Fixed 2023 demand data</a:t>
+            </a:r>
+          </a:p>
+          <a:p>
+            <a:pPr algn="l">
+              <a:lnSpc>
+                <a:spcPct val="112000"/>
+              </a:lnSpc>
+              <a:spcBef>
+                <a:spcPts val="0"/>
+              </a:spcBef>
+              <a:spcAft>
+                <a:spcPts val="0"/>
+              </a:spcAft>
+            </a:pPr>
+            <a:r>
+              <a:rPr sz="1584" b="0">
+                <a:solidFill>
+                  <a:srgbClr val="D4DEE6"/>
+                </a:solidFill>
+                <a:latin typeface="Segoe UI"/>
+              </a:rPr>
               <a:t>Allowed skill vocabulary</a:t>
             </a:r>
           </a:p>
@@ -8866,13 +9044,13 @@
               </a:spcAft>
             </a:pPr>
             <a:r>
-              <a:rPr sz="1655" b="0">
+              <a:rPr sz="1584" b="0">
                 <a:solidFill>
                   <a:srgbClr val="D4DEE6"/>
                 </a:solidFill>
                 <a:latin typeface="Segoe UI"/>
               </a:rPr>
-              <a:t>Fixed 2023 demand data</a:t>
+              <a:t>Match % = skill overlap</a:t>
             </a:r>
           </a:p>
         </p:txBody>
@@ -8885,7 +9063,7 @@
         </p:nvSpPr>
         <p:spPr>
           <a:xfrm>
-            <a:off x="7223760" y="4389120"/>
+            <a:off x="7223760" y="4206240"/>
             <a:ext cx="256032" cy="457200"/>
           </a:xfrm>
           <a:prstGeom prst="rect">
@@ -8975,33 +9153,33 @@
         </p:nvSpPr>
         <p:spPr>
           <a:xfrm>
-            <a:off x="7690104" y="3675887"/>
-            <a:ext cx="2606040" cy="585216"/>
-          </a:xfrm>
-          <a:prstGeom prst="rect">
-            <a:avLst/>
-          </a:prstGeom>
-          <a:noFill/>
-        </p:spPr>
-        <p:txBody>
-          <a:bodyPr wrap="square" lIns="0" rIns="0" tIns="0" bIns="0">
-            <a:spAutoFit/>
-          </a:bodyPr>
-          <a:lstStyle/>
-          <a:p>
-            <a:pPr algn="l">
-              <a:lnSpc>
-                <a:spcPct val="112000"/>
-              </a:lnSpc>
-              <a:spcBef>
-                <a:spcPts val="0"/>
-              </a:spcBef>
-              <a:spcAft>
-                <a:spcPts val="0"/>
-              </a:spcAft>
-            </a:pPr>
-            <a:r>
-              <a:rPr sz="3168" b="1">
+            <a:off x="7690104" y="3621024"/>
+            <a:ext cx="2606040" cy="512064"/>
+          </a:xfrm>
+          <a:prstGeom prst="rect">
+            <a:avLst/>
+          </a:prstGeom>
+          <a:noFill/>
+        </p:spPr>
+        <p:txBody>
+          <a:bodyPr wrap="square" lIns="0" rIns="0" tIns="0" bIns="0">
+            <a:spAutoFit/>
+          </a:bodyPr>
+          <a:lstStyle/>
+          <a:p>
+            <a:pPr algn="l">
+              <a:lnSpc>
+                <a:spcPct val="112000"/>
+              </a:lnSpc>
+              <a:spcBef>
+                <a:spcPts val="0"/>
+              </a:spcBef>
+              <a:spcAft>
+                <a:spcPts val="0"/>
+              </a:spcAft>
+            </a:pPr>
+            <a:r>
+              <a:rPr sz="2879" b="1">
                 <a:solidFill>
                   <a:srgbClr val="F27B43"/>
                 </a:solidFill>
@@ -9020,39 +9198,39 @@
         </p:nvSpPr>
         <p:spPr>
           <a:xfrm>
-            <a:off x="7690104" y="4361688"/>
-            <a:ext cx="2688336" cy="411480"/>
-          </a:xfrm>
-          <a:prstGeom prst="rect">
-            <a:avLst/>
-          </a:prstGeom>
-          <a:noFill/>
-        </p:spPr>
-        <p:txBody>
-          <a:bodyPr wrap="square" lIns="0" rIns="0" tIns="0" bIns="0">
-            <a:spAutoFit/>
-          </a:bodyPr>
-          <a:lstStyle/>
-          <a:p>
-            <a:pPr algn="l">
-              <a:lnSpc>
-                <a:spcPct val="112000"/>
-              </a:lnSpc>
-              <a:spcBef>
-                <a:spcPts val="0"/>
-              </a:spcBef>
-              <a:spcAft>
-                <a:spcPts val="0"/>
-              </a:spcAft>
-            </a:pPr>
-            <a:r>
-              <a:rPr sz="2232" b="1">
+            <a:off x="7690104" y="4187952"/>
+            <a:ext cx="2688336" cy="384048"/>
+          </a:xfrm>
+          <a:prstGeom prst="rect">
+            <a:avLst/>
+          </a:prstGeom>
+          <a:noFill/>
+        </p:spPr>
+        <p:txBody>
+          <a:bodyPr wrap="square" lIns="0" rIns="0" tIns="0" bIns="0">
+            <a:spAutoFit/>
+          </a:bodyPr>
+          <a:lstStyle/>
+          <a:p>
+            <a:pPr algn="l">
+              <a:lnSpc>
+                <a:spcPct val="112000"/>
+              </a:lnSpc>
+              <a:spcBef>
+                <a:spcPts val="0"/>
+              </a:spcBef>
+              <a:spcAft>
+                <a:spcPts val="0"/>
+              </a:spcAft>
+            </a:pPr>
+            <a:r>
+              <a:rPr sz="2160" b="1">
                 <a:solidFill>
                   <a:srgbClr val="F7F4EC"/>
                 </a:solidFill>
                 <a:latin typeface="Segoe UI"/>
               </a:rPr>
-              <a:t>AI advisor</a:t>
+              <a:t>AI + sources</a:t>
             </a:r>
           </a:p>
         </p:txBody>
@@ -9065,82 +9243,104 @@
         </p:nvSpPr>
         <p:spPr>
           <a:xfrm>
-            <a:off x="7690104" y="4892040"/>
-            <a:ext cx="2715768" cy="932688"/>
-          </a:xfrm>
-          <a:prstGeom prst="rect">
-            <a:avLst/>
-          </a:prstGeom>
-          <a:noFill/>
-        </p:spPr>
-        <p:txBody>
-          <a:bodyPr wrap="square" lIns="0" rIns="0" tIns="0" bIns="0">
-            <a:spAutoFit/>
-          </a:bodyPr>
-          <a:lstStyle/>
-          <a:p>
-            <a:pPr algn="l">
-              <a:lnSpc>
-                <a:spcPct val="112000"/>
-              </a:lnSpc>
-              <a:spcBef>
-                <a:spcPts val="0"/>
-              </a:spcBef>
-              <a:spcAft>
-                <a:spcPts val="0"/>
-              </a:spcAft>
-            </a:pPr>
-            <a:r>
-              <a:rPr sz="1655" b="0">
+            <a:off x="7690104" y="4681728"/>
+            <a:ext cx="2788920" cy="1078992"/>
+          </a:xfrm>
+          <a:prstGeom prst="rect">
+            <a:avLst/>
+          </a:prstGeom>
+          <a:noFill/>
+        </p:spPr>
+        <p:txBody>
+          <a:bodyPr wrap="square" lIns="0" rIns="0" tIns="0" bIns="0">
+            <a:spAutoFit/>
+          </a:bodyPr>
+          <a:lstStyle/>
+          <a:p>
+            <a:pPr algn="l">
+              <a:lnSpc>
+                <a:spcPct val="112000"/>
+              </a:lnSpc>
+              <a:spcBef>
+                <a:spcPts val="0"/>
+              </a:spcBef>
+              <a:spcAft>
+                <a:spcPts val="0"/>
+              </a:spcAft>
+            </a:pPr>
+            <a:r>
+              <a:rPr sz="1584" b="0">
                 <a:solidFill>
                   <a:srgbClr val="D4DEE6"/>
                 </a:solidFill>
                 <a:latin typeface="Segoe UI"/>
               </a:rPr>
-              <a:t>Groq-hosted inference</a:t>
-            </a:r>
-          </a:p>
-          <a:p>
-            <a:pPr algn="l">
-              <a:lnSpc>
-                <a:spcPct val="112000"/>
-              </a:lnSpc>
-              <a:spcBef>
-                <a:spcPts val="0"/>
-              </a:spcBef>
-              <a:spcAft>
-                <a:spcPts val="0"/>
-              </a:spcAft>
-            </a:pPr>
-            <a:r>
-              <a:rPr sz="1655" b="0">
+              <a:t>openai/gpt-oss-20b</a:t>
+            </a:r>
+          </a:p>
+          <a:p>
+            <a:pPr algn="l">
+              <a:lnSpc>
+                <a:spcPct val="112000"/>
+              </a:lnSpc>
+              <a:spcBef>
+                <a:spcPts val="0"/>
+              </a:spcBef>
+              <a:spcAft>
+                <a:spcPts val="0"/>
+              </a:spcAft>
+            </a:pPr>
+            <a:r>
+              <a:rPr sz="1584" b="0">
                 <a:solidFill>
                   <a:srgbClr val="D4DEE6"/>
                 </a:solidFill>
                 <a:latin typeface="Segoe UI"/>
               </a:rPr>
-              <a:t>openai/gpt-oss-20b</a:t>
-            </a:r>
-          </a:p>
-          <a:p>
-            <a:pPr algn="l">
-              <a:lnSpc>
-                <a:spcPct val="112000"/>
-              </a:lnSpc>
-              <a:spcBef>
-                <a:spcPts val="0"/>
-              </a:spcBef>
-              <a:spcAft>
-                <a:spcPts val="0"/>
-              </a:spcAft>
-            </a:pPr>
-            <a:r>
-              <a:rPr sz="1655" b="0">
+              <a:t>Groq browser search</a:t>
+            </a:r>
+          </a:p>
+          <a:p>
+            <a:pPr algn="l">
+              <a:lnSpc>
+                <a:spcPct val="112000"/>
+              </a:lnSpc>
+              <a:spcBef>
+                <a:spcPts val="0"/>
+              </a:spcBef>
+              <a:spcAft>
+                <a:spcPts val="0"/>
+              </a:spcAft>
+            </a:pPr>
+            <a:r>
+              <a:rPr sz="1584" b="0">
                 <a:solidFill>
                   <a:srgbClr val="D4DEE6"/>
                 </a:solidFill>
                 <a:latin typeface="Segoe UI"/>
               </a:rPr>
+              <a:t>Himalayas jobs API</a:t>
+            </a:r>
+          </a:p>
+          <a:p>
+            <a:pPr algn="l">
+              <a:lnSpc>
+                <a:spcPct val="112000"/>
+              </a:lnSpc>
+              <a:spcBef>
+                <a:spcPts val="0"/>
+              </a:spcBef>
+              <a:spcAft>
+                <a:spcPts val="0"/>
+              </a:spcAft>
+            </a:pPr>
+            <a:r>
+              <a:rPr sz="1584" b="0">
+                <a:solidFill>
+                  <a:srgbClr val="D4DEE6"/>
+                </a:solidFill>
+                <a:latin typeface="Segoe UI"/>
+              </a:rPr>
               <a:t>Structured JSON output</a:t>
             </a:r>
           </a:p>
@@ -9154,7 +9354,7 @@
         </p:nvSpPr>
         <p:spPr>
           <a:xfrm>
-            <a:off x="10607040" y="4389120"/>
+            <a:off x="10607040" y="4206240"/>
             <a:ext cx="256032" cy="457200"/>
           </a:xfrm>
           <a:prstGeom prst="rect">
@@ -9244,33 +9444,33 @@
         </p:nvSpPr>
         <p:spPr>
           <a:xfrm>
-            <a:off x="11073384" y="3675887"/>
-            <a:ext cx="2606040" cy="585216"/>
-          </a:xfrm>
-          <a:prstGeom prst="rect">
-            <a:avLst/>
-          </a:prstGeom>
-          <a:noFill/>
-        </p:spPr>
-        <p:txBody>
-          <a:bodyPr wrap="square" lIns="0" rIns="0" tIns="0" bIns="0">
-            <a:spAutoFit/>
-          </a:bodyPr>
-          <a:lstStyle/>
-          <a:p>
-            <a:pPr algn="l">
-              <a:lnSpc>
-                <a:spcPct val="112000"/>
-              </a:lnSpc>
-              <a:spcBef>
-                <a:spcPts val="0"/>
-              </a:spcBef>
-              <a:spcAft>
-                <a:spcPts val="0"/>
-              </a:spcAft>
-            </a:pPr>
-            <a:r>
-              <a:rPr sz="3168" b="1">
+            <a:off x="11073384" y="3621024"/>
+            <a:ext cx="2606040" cy="512064"/>
+          </a:xfrm>
+          <a:prstGeom prst="rect">
+            <a:avLst/>
+          </a:prstGeom>
+          <a:noFill/>
+        </p:spPr>
+        <p:txBody>
+          <a:bodyPr wrap="square" lIns="0" rIns="0" tIns="0" bIns="0">
+            <a:spAutoFit/>
+          </a:bodyPr>
+          <a:lstStyle/>
+          <a:p>
+            <a:pPr algn="l">
+              <a:lnSpc>
+                <a:spcPct val="112000"/>
+              </a:lnSpc>
+              <a:spcBef>
+                <a:spcPts val="0"/>
+              </a:spcBef>
+              <a:spcAft>
+                <a:spcPts val="0"/>
+              </a:spcAft>
+            </a:pPr>
+            <a:r>
+              <a:rPr sz="2879" b="1">
                 <a:solidFill>
                   <a:srgbClr val="F27B43"/>
                 </a:solidFill>
@@ -9289,39 +9489,39 @@
         </p:nvSpPr>
         <p:spPr>
           <a:xfrm>
-            <a:off x="11073384" y="4361688"/>
-            <a:ext cx="2688336" cy="411480"/>
-          </a:xfrm>
-          <a:prstGeom prst="rect">
-            <a:avLst/>
-          </a:prstGeom>
-          <a:noFill/>
-        </p:spPr>
-        <p:txBody>
-          <a:bodyPr wrap="square" lIns="0" rIns="0" tIns="0" bIns="0">
-            <a:spAutoFit/>
-          </a:bodyPr>
-          <a:lstStyle/>
-          <a:p>
-            <a:pPr algn="l">
-              <a:lnSpc>
-                <a:spcPct val="112000"/>
-              </a:lnSpc>
-              <a:spcBef>
-                <a:spcPts val="0"/>
-              </a:spcBef>
-              <a:spcAft>
-                <a:spcPts val="0"/>
-              </a:spcAft>
-            </a:pPr>
-            <a:r>
-              <a:rPr sz="2232" b="1">
+            <a:off x="11073384" y="4187952"/>
+            <a:ext cx="2688336" cy="384048"/>
+          </a:xfrm>
+          <a:prstGeom prst="rect">
+            <a:avLst/>
+          </a:prstGeom>
+          <a:noFill/>
+        </p:spPr>
+        <p:txBody>
+          <a:bodyPr wrap="square" lIns="0" rIns="0" tIns="0" bIns="0">
+            <a:spAutoFit/>
+          </a:bodyPr>
+          <a:lstStyle/>
+          <a:p>
+            <a:pPr algn="l">
+              <a:lnSpc>
+                <a:spcPct val="112000"/>
+              </a:lnSpc>
+              <a:spcBef>
+                <a:spcPts val="0"/>
+              </a:spcBef>
+              <a:spcAft>
+                <a:spcPts val="0"/>
+              </a:spcAft>
+            </a:pPr>
+            <a:r>
+              <a:rPr sz="2160" b="1">
                 <a:solidFill>
                   <a:srgbClr val="F7F4EC"/>
                 </a:solidFill>
                 <a:latin typeface="Segoe UI"/>
               </a:rPr>
-              <a:t>Checked advice</a:t>
+              <a:t>Checked output</a:t>
             </a:r>
           </a:p>
         </p:txBody>
@@ -9334,83 +9534,105 @@
         </p:nvSpPr>
         <p:spPr>
           <a:xfrm>
-            <a:off x="11073384" y="4892040"/>
-            <a:ext cx="2715768" cy="932688"/>
-          </a:xfrm>
-          <a:prstGeom prst="rect">
-            <a:avLst/>
-          </a:prstGeom>
-          <a:noFill/>
-        </p:spPr>
-        <p:txBody>
-          <a:bodyPr wrap="square" lIns="0" rIns="0" tIns="0" bIns="0">
-            <a:spAutoFit/>
-          </a:bodyPr>
-          <a:lstStyle/>
-          <a:p>
-            <a:pPr algn="l">
-              <a:lnSpc>
-                <a:spcPct val="112000"/>
-              </a:lnSpc>
-              <a:spcBef>
-                <a:spcPts val="0"/>
-              </a:spcBef>
-              <a:spcAft>
-                <a:spcPts val="0"/>
-              </a:spcAft>
-            </a:pPr>
-            <a:r>
-              <a:rPr sz="1655" b="0">
+            <a:off x="11073384" y="4681728"/>
+            <a:ext cx="2788920" cy="1078992"/>
+          </a:xfrm>
+          <a:prstGeom prst="rect">
+            <a:avLst/>
+          </a:prstGeom>
+          <a:noFill/>
+        </p:spPr>
+        <p:txBody>
+          <a:bodyPr wrap="square" lIns="0" rIns="0" tIns="0" bIns="0">
+            <a:spAutoFit/>
+          </a:bodyPr>
+          <a:lstStyle/>
+          <a:p>
+            <a:pPr algn="l">
+              <a:lnSpc>
+                <a:spcPct val="112000"/>
+              </a:lnSpc>
+              <a:spcBef>
+                <a:spcPts val="0"/>
+              </a:spcBef>
+              <a:spcAft>
+                <a:spcPts val="0"/>
+              </a:spcAft>
+            </a:pPr>
+            <a:r>
+              <a:rPr sz="1584" b="0">
                 <a:solidFill>
                   <a:srgbClr val="D4DEE6"/>
                 </a:solidFill>
                 <a:latin typeface="Segoe UI"/>
               </a:rPr>
-              <a:t>Schema + quote checks</a:t>
-            </a:r>
-          </a:p>
-          <a:p>
-            <a:pPr algn="l">
-              <a:lnSpc>
-                <a:spcPct val="112000"/>
-              </a:lnSpc>
-              <a:spcBef>
-                <a:spcPts val="0"/>
-              </a:spcBef>
-              <a:spcAft>
-                <a:spcPts val="0"/>
-              </a:spcAft>
-            </a:pPr>
-            <a:r>
-              <a:rPr sz="1655" b="0">
+              <a:t>Quote + rewrite checks</a:t>
+            </a:r>
+          </a:p>
+          <a:p>
+            <a:pPr algn="l">
+              <a:lnSpc>
+                <a:spcPct val="112000"/>
+              </a:lnSpc>
+              <a:spcBef>
+                <a:spcPts val="0"/>
+              </a:spcBef>
+              <a:spcAft>
+                <a:spcPts val="0"/>
+              </a:spcAft>
+            </a:pPr>
+            <a:r>
+              <a:rPr sz="1584" b="0">
                 <a:solidFill>
                   <a:srgbClr val="D4DEE6"/>
                 </a:solidFill>
                 <a:latin typeface="Segoe UI"/>
               </a:rPr>
-              <a:t>Rewrite number/tool checks</a:t>
-            </a:r>
-          </a:p>
-          <a:p>
-            <a:pPr algn="l">
-              <a:lnSpc>
-                <a:spcPct val="112000"/>
-              </a:lnSpc>
-              <a:spcBef>
-                <a:spcPts val="0"/>
-              </a:spcBef>
-              <a:spcAft>
-                <a:spcPts val="0"/>
-              </a:spcAft>
-            </a:pPr>
-            <a:r>
-              <a:rPr sz="1655" b="0">
+              <a:t>Web results kept only</a:t>
+            </a:r>
+          </a:p>
+          <a:p>
+            <a:pPr algn="l">
+              <a:lnSpc>
+                <a:spcPct val="112000"/>
+              </a:lnSpc>
+              <a:spcBef>
+                <a:spcPts val="0"/>
+              </a:spcBef>
+              <a:spcAft>
+                <a:spcPts val="0"/>
+              </a:spcAft>
+            </a:pPr>
+            <a:r>
+              <a:rPr sz="1584" b="0">
                 <a:solidFill>
                   <a:srgbClr val="D4DEE6"/>
                 </a:solidFill>
                 <a:latin typeface="Segoe UI"/>
               </a:rPr>
-              <a:t>Strengths → plan → practice</a:t>
+              <a:t>if URL is in evidence</a:t>
+            </a:r>
+          </a:p>
+          <a:p>
+            <a:pPr algn="l">
+              <a:lnSpc>
+                <a:spcPct val="112000"/>
+              </a:lnSpc>
+              <a:spcBef>
+                <a:spcPts val="0"/>
+              </a:spcBef>
+              <a:spcAft>
+                <a:spcPts val="0"/>
+              </a:spcAft>
+            </a:pPr>
+            <a:r>
+              <a:rPr sz="1584" b="0">
+                <a:solidFill>
+                  <a:srgbClr val="D4DEE6"/>
+                </a:solidFill>
+                <a:latin typeface="Segoe UI"/>
+              </a:rPr>
+              <a:t>No-new-facts feedback</a:t>
             </a:r>
           </a:p>
         </p:txBody>
@@ -9500,7 +9722,7 @@
                 </a:solidFill>
                 <a:latin typeface="Segoe UI"/>
               </a:rPr>
-              <a:t>RESILIENT BY DESIGN</a:t>
+              <a:t>PRIVACY BOUNDARY</a:t>
             </a:r>
           </a:p>
         </p:txBody>
@@ -9513,8 +9735,8 @@
         </p:nvSpPr>
         <p:spPr>
           <a:xfrm>
-            <a:off x="4754880" y="6382512"/>
-            <a:ext cx="8915400" cy="338328"/>
+            <a:off x="4297680" y="6382512"/>
+            <a:ext cx="9418320" cy="338328"/>
           </a:xfrm>
           <a:prstGeom prst="rect">
             <a:avLst/>
@@ -9545,7 +9767,7 @@
                 </a:solidFill>
                 <a:latin typeface="Segoe UI"/>
               </a:rPr>
-              <a:t>Model unavailable or output rejected → rules-based guidance</a:t>
+              <a:t>Web search gets role, country + skill names — never CV text</a:t>
             </a:r>
           </a:p>
         </p:txBody>
@@ -9590,7 +9812,7 @@
                 </a:solidFill>
                 <a:latin typeface="Segoe UI"/>
               </a:rPr>
-              <a:t>Best-effort PII redaction · CV text sent to AI only with opt-in · no application database persistence</a:t>
+              <a:t>Opt-in for CV + practice · Groq → NVIDIA backup (same 20b model) · web search: Groq only</a:t>
             </a:r>
           </a:p>
         </p:txBody>
@@ -9794,7 +10016,7 @@
                 </a:solidFill>
                 <a:latin typeface="Segoe UI"/>
               </a:rPr>
-              <a:t>Public desktop + 390 × 844 mobile-browser checks passed. Editable panels below illustrate the journey.</a:t>
+              <a:t>Built for phone browsers — no app install. Editable panels below illustrate the new journey.</a:t>
             </a:r>
           </a:p>
         </p:txBody>
@@ -10017,7 +10239,7 @@
                 </a:solidFill>
                 <a:latin typeface="Segoe UI"/>
               </a:rPr>
-              <a:t>CV + role + permission</a:t>
+              <a:t>CV + role + follow-up answers</a:t>
             </a:r>
           </a:p>
         </p:txBody>
@@ -10210,7 +10432,7 @@
         </p:nvSpPr>
         <p:spPr>
           <a:xfrm>
-            <a:off x="1389888" y="5020056"/>
+            <a:off x="1389888" y="4983480"/>
             <a:ext cx="2560320" cy="292608"/>
           </a:xfrm>
           <a:prstGeom prst="rect">
@@ -10242,7 +10464,7 @@
                 </a:solidFill>
                 <a:latin typeface="Segoe UI"/>
               </a:rPr>
-              <a:t>YOUR NEXT ROLE</a:t>
+              <a:t>NJIA ASKS · 2 OF 4</a:t>
             </a:r>
           </a:p>
         </p:txBody>
@@ -10255,39 +10477,39 @@
         </p:nvSpPr>
         <p:spPr>
           <a:xfrm>
-            <a:off x="1389888" y="5358384"/>
-            <a:ext cx="2697480" cy="301752"/>
-          </a:xfrm>
-          <a:prstGeom prst="rect">
-            <a:avLst/>
-          </a:prstGeom>
-          <a:noFill/>
-        </p:spPr>
-        <p:txBody>
-          <a:bodyPr wrap="square" lIns="0" rIns="0" tIns="0" bIns="0">
-            <a:spAutoFit/>
-          </a:bodyPr>
-          <a:lstStyle/>
-          <a:p>
-            <a:pPr algn="l">
-              <a:lnSpc>
-                <a:spcPct val="112000"/>
-              </a:lnSpc>
-              <a:spcBef>
-                <a:spcPts val="0"/>
-              </a:spcBef>
-              <a:spcAft>
-                <a:spcPts val="0"/>
-              </a:spcAft>
-            </a:pPr>
-            <a:r>
-              <a:rPr sz="1655" b="1">
+            <a:off x="1389888" y="5276088"/>
+            <a:ext cx="2706624" cy="274320"/>
+          </a:xfrm>
+          <a:prstGeom prst="rect">
+            <a:avLst/>
+          </a:prstGeom>
+          <a:noFill/>
+        </p:spPr>
+        <p:txBody>
+          <a:bodyPr wrap="square" lIns="0" rIns="0" tIns="0" bIns="0">
+            <a:spAutoFit/>
+          </a:bodyPr>
+          <a:lstStyle/>
+          <a:p>
+            <a:pPr algn="l">
+              <a:lnSpc>
+                <a:spcPct val="112000"/>
+              </a:lnSpc>
+              <a:spcBef>
+                <a:spcPts val="0"/>
+              </a:spcBef>
+              <a:spcAft>
+                <a:spcPts val="0"/>
+              </a:spcAft>
+            </a:pPr>
+            <a:r>
+              <a:rPr sz="1512" b="1">
                 <a:solidFill>
                   <a:srgbClr val="1B2D40"/>
                 </a:solidFill>
                 <a:latin typeface="Segoe UI"/>
               </a:rPr>
-              <a:t>Kenya  /  Data Analyst</a:t>
+              <a:t>How have you used SQL?</a:t>
             </a:r>
           </a:p>
         </p:txBody>
@@ -10300,12 +10522,12 @@
         </p:nvSpPr>
         <p:spPr>
           <a:xfrm>
-            <a:off x="1371600" y="5769864"/>
-            <a:ext cx="2761488" cy="621792"/>
+            <a:off x="1371600" y="5641848"/>
+            <a:ext cx="2761488" cy="301752"/>
           </a:xfrm>
           <a:prstGeom prst="roundRect">
             <a:avLst>
-              <a:gd name="adj" fmla="val 8823"/>
+              <a:gd name="adj" fmla="val 18181"/>
             </a:avLst>
           </a:prstGeom>
           <a:solidFill>
@@ -10345,102 +10567,57 @@
         </p:nvSpPr>
         <p:spPr>
           <a:xfrm>
-            <a:off x="1490472" y="5961888"/>
-            <a:ext cx="2468880" cy="283464"/>
-          </a:xfrm>
-          <a:prstGeom prst="rect">
-            <a:avLst/>
-          </a:prstGeom>
-          <a:noFill/>
-        </p:spPr>
-        <p:txBody>
-          <a:bodyPr wrap="square" lIns="0" rIns="0" tIns="0" bIns="0">
-            <a:spAutoFit/>
-          </a:bodyPr>
-          <a:lstStyle/>
-          <a:p>
-            <a:pPr algn="l">
-              <a:lnSpc>
-                <a:spcPct val="112000"/>
-              </a:lnSpc>
-              <a:spcBef>
-                <a:spcPts val="0"/>
-              </a:spcBef>
-              <a:spcAft>
-                <a:spcPts val="0"/>
-              </a:spcAft>
-            </a:pPr>
-            <a:r>
-              <a:rPr sz="1512" b="0">
-                <a:solidFill>
-                  <a:srgbClr val="586777"/>
-                </a:solidFill>
-                <a:latin typeface="Segoe UI"/>
-              </a:rPr>
-              <a:t>Paste or upload your CV</a:t>
-            </a:r>
-          </a:p>
-        </p:txBody>
-      </p:sp>
-      <p:sp>
-        <p:nvSpPr>
-          <p:cNvPr id="19" name="TextBox 18"/>
-          <p:cNvSpPr txBox="1"/>
-          <p:nvPr/>
-        </p:nvSpPr>
-        <p:spPr>
-          <a:xfrm>
-            <a:off x="1389888" y="6528816"/>
-            <a:ext cx="2670048" cy="292608"/>
-          </a:xfrm>
-          <a:prstGeom prst="rect">
-            <a:avLst/>
-          </a:prstGeom>
-          <a:noFill/>
-        </p:spPr>
-        <p:txBody>
-          <a:bodyPr wrap="square" lIns="0" rIns="0" tIns="0" bIns="0">
-            <a:spAutoFit/>
-          </a:bodyPr>
-          <a:lstStyle/>
-          <a:p>
-            <a:pPr algn="l">
-              <a:lnSpc>
-                <a:spcPct val="112000"/>
-              </a:lnSpc>
-              <a:spcBef>
-                <a:spcPts val="0"/>
-              </a:spcBef>
-              <a:spcAft>
-                <a:spcPts val="0"/>
-              </a:spcAft>
-            </a:pPr>
-            <a:r>
-              <a:rPr sz="1368" b="0">
-                <a:solidFill>
-                  <a:srgbClr val="586777"/>
-                </a:solidFill>
-                <a:latin typeface="Segoe UI"/>
-              </a:rPr>
-              <a:t>Opt in to send CV text to AI</a:t>
-            </a:r>
-          </a:p>
-        </p:txBody>
-      </p:sp>
-      <p:sp>
-        <p:nvSpPr>
-          <p:cNvPr id="20" name="Rounded Rectangle 19"/>
+            <a:off x="1481328" y="5687568"/>
+            <a:ext cx="2596896" cy="219456"/>
+          </a:xfrm>
+          <a:prstGeom prst="rect">
+            <a:avLst/>
+          </a:prstGeom>
+          <a:noFill/>
+        </p:spPr>
+        <p:txBody>
+          <a:bodyPr wrap="square" lIns="0" rIns="0" tIns="0" bIns="0">
+            <a:spAutoFit/>
+          </a:bodyPr>
+          <a:lstStyle/>
+          <a:p>
+            <a:pPr algn="l">
+              <a:lnSpc>
+                <a:spcPct val="112000"/>
+              </a:lnSpc>
+              <a:spcBef>
+                <a:spcPts val="0"/>
+              </a:spcBef>
+              <a:spcAft>
+                <a:spcPts val="0"/>
+              </a:spcAft>
+            </a:pPr>
+            <a:r>
+              <a:rPr sz="1224" b="0">
+                <a:solidFill>
+                  <a:srgbClr val="1B2D40"/>
+                </a:solidFill>
+                <a:latin typeface="Segoe UI"/>
+              </a:rPr>
+              <a:t>Used it at work</a:t>
+            </a:r>
+          </a:p>
+        </p:txBody>
+      </p:sp>
+      <p:sp>
+        <p:nvSpPr>
+          <p:cNvPr id="19" name="Rounded Rectangle 18"/>
           <p:cNvSpPr/>
           <p:nvPr/>
         </p:nvSpPr>
         <p:spPr>
           <a:xfrm>
-            <a:off x="1371600" y="6885432"/>
-            <a:ext cx="2761488" cy="256032"/>
+            <a:off x="1371600" y="6007608"/>
+            <a:ext cx="2761488" cy="301752"/>
           </a:xfrm>
           <a:prstGeom prst="roundRect">
             <a:avLst>
-              <a:gd name="adj" fmla="val 17857"/>
+              <a:gd name="adj" fmla="val 18181"/>
             </a:avLst>
           </a:prstGeom>
           <a:solidFill>
@@ -10474,52 +10651,232 @@
       </p:sp>
       <p:sp>
         <p:nvSpPr>
-          <p:cNvPr id="21" name="TextBox 20"/>
-          <p:cNvSpPr txBox="1"/>
-          <p:nvPr/>
-        </p:nvSpPr>
-        <p:spPr>
-          <a:xfrm>
-            <a:off x="1408176" y="6903720"/>
-            <a:ext cx="2688336" cy="228600"/>
-          </a:xfrm>
-          <a:prstGeom prst="rect">
-            <a:avLst/>
-          </a:prstGeom>
-          <a:noFill/>
-        </p:spPr>
-        <p:txBody>
-          <a:bodyPr wrap="square" lIns="0" rIns="0" tIns="0" bIns="0">
-            <a:spAutoFit/>
-          </a:bodyPr>
-          <a:lstStyle/>
-          <a:p>
-            <a:pPr algn="ctr">
-              <a:lnSpc>
-                <a:spcPct val="112000"/>
-              </a:lnSpc>
-              <a:spcBef>
-                <a:spcPts val="0"/>
-              </a:spcBef>
-              <a:spcAft>
-                <a:spcPts val="0"/>
-              </a:spcAft>
-            </a:pPr>
-            <a:r>
-              <a:rPr sz="1296" b="1">
+          <p:cNvPr id="20" name="TextBox 19"/>
+          <p:cNvSpPr txBox="1"/>
+          <p:nvPr/>
+        </p:nvSpPr>
+        <p:spPr>
+          <a:xfrm>
+            <a:off x="1481328" y="6053328"/>
+            <a:ext cx="2596896" cy="219456"/>
+          </a:xfrm>
+          <a:prstGeom prst="rect">
+            <a:avLst/>
+          </a:prstGeom>
+          <a:noFill/>
+        </p:spPr>
+        <p:txBody>
+          <a:bodyPr wrap="square" lIns="0" rIns="0" tIns="0" bIns="0">
+            <a:spAutoFit/>
+          </a:bodyPr>
+          <a:lstStyle/>
+          <a:p>
+            <a:pPr algn="l">
+              <a:lnSpc>
+                <a:spcPct val="112000"/>
+              </a:lnSpc>
+              <a:spcBef>
+                <a:spcPts val="0"/>
+              </a:spcBef>
+              <a:spcAft>
+                <a:spcPts val="0"/>
+              </a:spcAft>
+            </a:pPr>
+            <a:r>
+              <a:rPr sz="1224" b="1">
                 <a:solidFill>
                   <a:srgbClr val="14283F"/>
                 </a:solidFill>
                 <a:latin typeface="Segoe UI"/>
               </a:rPr>
-              <a:t>Assess my CV</a:t>
-            </a:r>
+              <a:t>Used it in a project or course</a:t>
+            </a:r>
+          </a:p>
+        </p:txBody>
+      </p:sp>
+      <p:sp>
+        <p:nvSpPr>
+          <p:cNvPr id="21" name="Rounded Rectangle 20"/>
+          <p:cNvSpPr/>
+          <p:nvPr/>
+        </p:nvSpPr>
+        <p:spPr>
+          <a:xfrm>
+            <a:off x="1371600" y="6373368"/>
+            <a:ext cx="2761488" cy="301752"/>
+          </a:xfrm>
+          <a:prstGeom prst="roundRect">
+            <a:avLst>
+              <a:gd name="adj" fmla="val 18181"/>
+            </a:avLst>
+          </a:prstGeom>
+          <a:solidFill>
+            <a:srgbClr val="F7F4EC"/>
+          </a:solidFill>
+          <a:ln>
+            <a:noFill/>
+          </a:ln>
+        </p:spPr>
+        <p:style>
+          <a:lnRef idx="1">
+            <a:schemeClr val="accent1"/>
+          </a:lnRef>
+          <a:fillRef idx="3">
+            <a:schemeClr val="accent1"/>
+          </a:fillRef>
+          <a:effectRef idx="2">
+            <a:schemeClr val="accent1"/>
+          </a:effectRef>
+          <a:fontRef idx="minor">
+            <a:schemeClr val="lt1"/>
+          </a:fontRef>
+        </p:style>
+        <p:txBody>
+          <a:bodyPr rtlCol="0" anchor="ctr"/>
+          <a:lstStyle/>
+          <a:p>
+            <a:pPr algn="ctr"/>
           </a:p>
         </p:txBody>
       </p:sp>
       <p:sp>
         <p:nvSpPr>
           <p:cNvPr id="22" name="TextBox 21"/>
+          <p:cNvSpPr txBox="1"/>
+          <p:nvPr/>
+        </p:nvSpPr>
+        <p:spPr>
+          <a:xfrm>
+            <a:off x="1481328" y="6419088"/>
+            <a:ext cx="2596896" cy="219456"/>
+          </a:xfrm>
+          <a:prstGeom prst="rect">
+            <a:avLst/>
+          </a:prstGeom>
+          <a:noFill/>
+        </p:spPr>
+        <p:txBody>
+          <a:bodyPr wrap="square" lIns="0" rIns="0" tIns="0" bIns="0">
+            <a:spAutoFit/>
+          </a:bodyPr>
+          <a:lstStyle/>
+          <a:p>
+            <a:pPr algn="l">
+              <a:lnSpc>
+                <a:spcPct val="112000"/>
+              </a:lnSpc>
+              <a:spcBef>
+                <a:spcPts val="0"/>
+              </a:spcBef>
+              <a:spcAft>
+                <a:spcPts val="0"/>
+              </a:spcAft>
+            </a:pPr>
+            <a:r>
+              <a:rPr sz="1224" b="0">
+                <a:solidFill>
+                  <a:srgbClr val="1B2D40"/>
+                </a:solidFill>
+                <a:latin typeface="Segoe UI"/>
+              </a:rPr>
+              <a:t>Still learning it</a:t>
+            </a:r>
+          </a:p>
+        </p:txBody>
+      </p:sp>
+      <p:sp>
+        <p:nvSpPr>
+          <p:cNvPr id="23" name="Rounded Rectangle 22"/>
+          <p:cNvSpPr/>
+          <p:nvPr/>
+        </p:nvSpPr>
+        <p:spPr>
+          <a:xfrm>
+            <a:off x="1371600" y="6739128"/>
+            <a:ext cx="2761488" cy="301752"/>
+          </a:xfrm>
+          <a:prstGeom prst="roundRect">
+            <a:avLst>
+              <a:gd name="adj" fmla="val 18181"/>
+            </a:avLst>
+          </a:prstGeom>
+          <a:solidFill>
+            <a:srgbClr val="F7F4EC"/>
+          </a:solidFill>
+          <a:ln>
+            <a:noFill/>
+          </a:ln>
+        </p:spPr>
+        <p:style>
+          <a:lnRef idx="1">
+            <a:schemeClr val="accent1"/>
+          </a:lnRef>
+          <a:fillRef idx="3">
+            <a:schemeClr val="accent1"/>
+          </a:fillRef>
+          <a:effectRef idx="2">
+            <a:schemeClr val="accent1"/>
+          </a:effectRef>
+          <a:fontRef idx="minor">
+            <a:schemeClr val="lt1"/>
+          </a:fontRef>
+        </p:style>
+        <p:txBody>
+          <a:bodyPr rtlCol="0" anchor="ctr"/>
+          <a:lstStyle/>
+          <a:p>
+            <a:pPr algn="ctr"/>
+          </a:p>
+        </p:txBody>
+      </p:sp>
+      <p:sp>
+        <p:nvSpPr>
+          <p:cNvPr id="24" name="TextBox 23"/>
+          <p:cNvSpPr txBox="1"/>
+          <p:nvPr/>
+        </p:nvSpPr>
+        <p:spPr>
+          <a:xfrm>
+            <a:off x="1481328" y="6784848"/>
+            <a:ext cx="2596896" cy="219456"/>
+          </a:xfrm>
+          <a:prstGeom prst="rect">
+            <a:avLst/>
+          </a:prstGeom>
+          <a:noFill/>
+        </p:spPr>
+        <p:txBody>
+          <a:bodyPr wrap="square" lIns="0" rIns="0" tIns="0" bIns="0">
+            <a:spAutoFit/>
+          </a:bodyPr>
+          <a:lstStyle/>
+          <a:p>
+            <a:pPr algn="l">
+              <a:lnSpc>
+                <a:spcPct val="112000"/>
+              </a:lnSpc>
+              <a:spcBef>
+                <a:spcPts val="0"/>
+              </a:spcBef>
+              <a:spcAft>
+                <a:spcPts val="0"/>
+              </a:spcAft>
+            </a:pPr>
+            <a:r>
+              <a:rPr sz="1224" b="0">
+                <a:solidFill>
+                  <a:srgbClr val="1B2D40"/>
+                </a:solidFill>
+                <a:latin typeface="Segoe UI"/>
+              </a:rPr>
+              <a:t>Not yet</a:t>
+            </a:r>
+          </a:p>
+        </p:txBody>
+      </p:sp>
+      <p:sp>
+        <p:nvSpPr>
+          <p:cNvPr id="25" name="TextBox 24"/>
           <p:cNvSpPr txBox="1"/>
           <p:nvPr/>
         </p:nvSpPr>
@@ -10557,14 +10914,14 @@
                 </a:solidFill>
                 <a:latin typeface="Segoe UI"/>
               </a:rPr>
-              <a:t>02 / Read the evidence</a:t>
-            </a:r>
-          </a:p>
-        </p:txBody>
-      </p:sp>
-      <p:sp>
-        <p:nvSpPr>
-          <p:cNvPr id="23" name="TextBox 22"/>
+              <a:t>02 / Match live jobs</a:t>
+            </a:r>
+          </a:p>
+        </p:txBody>
+      </p:sp>
+      <p:sp>
+        <p:nvSpPr>
+          <p:cNvPr id="26" name="TextBox 25"/>
           <p:cNvSpPr txBox="1"/>
           <p:nvPr/>
         </p:nvSpPr>
@@ -10602,14 +10959,14 @@
                 </a:solidFill>
                 <a:latin typeface="Segoe UI"/>
               </a:rPr>
-              <a:t>Strengths + local priorities</a:t>
-            </a:r>
-          </a:p>
-        </p:txBody>
-      </p:sp>
-      <p:sp>
-        <p:nvSpPr>
-          <p:cNvPr id="24" name="Rounded Rectangle 23"/>
+              <a:t>Open to Kenya + skill match %</a:t>
+            </a:r>
+          </a:p>
+        </p:txBody>
+      </p:sp>
+      <p:sp>
+        <p:nvSpPr>
+          <p:cNvPr id="27" name="Rounded Rectangle 26"/>
           <p:cNvSpPr/>
           <p:nvPr/>
         </p:nvSpPr>
@@ -10654,7 +11011,7 @@
       </p:sp>
       <p:sp>
         <p:nvSpPr>
-          <p:cNvPr id="25" name="Rounded Rectangle 24"/>
+          <p:cNvPr id="28" name="Rounded Rectangle 27"/>
           <p:cNvSpPr/>
           <p:nvPr/>
         </p:nvSpPr>
@@ -10699,7 +11056,7 @@
       </p:sp>
       <p:sp>
         <p:nvSpPr>
-          <p:cNvPr id="26" name="Rounded Rectangle 25"/>
+          <p:cNvPr id="29" name="Rounded Rectangle 28"/>
           <p:cNvSpPr/>
           <p:nvPr/>
         </p:nvSpPr>
@@ -10744,7 +11101,7 @@
       </p:sp>
       <p:sp>
         <p:nvSpPr>
-          <p:cNvPr id="27" name="TextBox 26"/>
+          <p:cNvPr id="30" name="TextBox 29"/>
           <p:cNvSpPr txBox="1"/>
           <p:nvPr/>
         </p:nvSpPr>
@@ -10789,13 +11146,13 @@
       </p:sp>
       <p:sp>
         <p:nvSpPr>
-          <p:cNvPr id="28" name="TextBox 27"/>
-          <p:cNvSpPr txBox="1"/>
-          <p:nvPr/>
-        </p:nvSpPr>
-        <p:spPr>
-          <a:xfrm>
-            <a:off x="5916168" y="5020056"/>
+          <p:cNvPr id="31" name="TextBox 30"/>
+          <p:cNvSpPr txBox="1"/>
+          <p:nvPr/>
+        </p:nvSpPr>
+        <p:spPr>
+          <a:xfrm>
+            <a:off x="5916168" y="4983480"/>
             <a:ext cx="2697480" cy="292608"/>
           </a:xfrm>
           <a:prstGeom prst="rect">
@@ -10827,115 +11184,115 @@
                 </a:solidFill>
                 <a:latin typeface="Segoe UI"/>
               </a:rPr>
-              <a:t>EVIDENCE IN YOUR CV</a:t>
-            </a:r>
-          </a:p>
-        </p:txBody>
-      </p:sp>
-      <p:sp>
-        <p:nvSpPr>
-          <p:cNvPr id="29" name="TextBox 28"/>
-          <p:cNvSpPr txBox="1"/>
-          <p:nvPr/>
-        </p:nvSpPr>
-        <p:spPr>
-          <a:xfrm>
-            <a:off x="5916168" y="5376672"/>
-            <a:ext cx="2706624" cy="320040"/>
-          </a:xfrm>
-          <a:prstGeom prst="rect">
-            <a:avLst/>
-          </a:prstGeom>
-          <a:noFill/>
-        </p:spPr>
-        <p:txBody>
-          <a:bodyPr wrap="square" lIns="0" rIns="0" tIns="0" bIns="0">
-            <a:spAutoFit/>
-          </a:bodyPr>
-          <a:lstStyle/>
-          <a:p>
-            <a:pPr algn="l">
-              <a:lnSpc>
-                <a:spcPct val="112000"/>
-              </a:lnSpc>
-              <a:spcBef>
-                <a:spcPts val="0"/>
-              </a:spcBef>
-              <a:spcAft>
-                <a:spcPts val="0"/>
-              </a:spcAft>
-            </a:pPr>
-            <a:r>
-              <a:rPr sz="1728" b="1">
+              <a:t>LIVE · OPEN TO KENYA</a:t>
+            </a:r>
+          </a:p>
+        </p:txBody>
+      </p:sp>
+      <p:sp>
+        <p:nvSpPr>
+          <p:cNvPr id="32" name="TextBox 31"/>
+          <p:cNvSpPr txBox="1"/>
+          <p:nvPr/>
+        </p:nvSpPr>
+        <p:spPr>
+          <a:xfrm>
+            <a:off x="5916168" y="5276088"/>
+            <a:ext cx="2706624" cy="274320"/>
+          </a:xfrm>
+          <a:prstGeom prst="rect">
+            <a:avLst/>
+          </a:prstGeom>
+          <a:noFill/>
+        </p:spPr>
+        <p:txBody>
+          <a:bodyPr wrap="square" lIns="0" rIns="0" tIns="0" bIns="0">
+            <a:spAutoFit/>
+          </a:bodyPr>
+          <a:lstStyle/>
+          <a:p>
+            <a:pPr algn="l">
+              <a:lnSpc>
+                <a:spcPct val="112000"/>
+              </a:lnSpc>
+              <a:spcBef>
+                <a:spcPts val="0"/>
+              </a:spcBef>
+              <a:spcAft>
+                <a:spcPts val="0"/>
+              </a:spcAft>
+            </a:pPr>
+            <a:r>
+              <a:rPr sz="1584" b="1">
                 <a:solidFill>
                   <a:srgbClr val="1B2D40"/>
                 </a:solidFill>
                 <a:latin typeface="Segoe UI"/>
               </a:rPr>
-              <a:t>Excel data preparation</a:t>
-            </a:r>
-          </a:p>
-        </p:txBody>
-      </p:sp>
-      <p:sp>
-        <p:nvSpPr>
-          <p:cNvPr id="30" name="TextBox 29"/>
-          <p:cNvSpPr txBox="1"/>
-          <p:nvPr/>
-        </p:nvSpPr>
-        <p:spPr>
-          <a:xfrm>
-            <a:off x="5916168" y="5779008"/>
-            <a:ext cx="2651760" cy="557784"/>
-          </a:xfrm>
-          <a:prstGeom prst="rect">
-            <a:avLst/>
-          </a:prstGeom>
-          <a:noFill/>
-        </p:spPr>
-        <p:txBody>
-          <a:bodyPr wrap="square" lIns="0" rIns="0" tIns="0" bIns="0">
-            <a:spAutoFit/>
-          </a:bodyPr>
-          <a:lstStyle/>
-          <a:p>
-            <a:pPr algn="l">
-              <a:lnSpc>
-                <a:spcPct val="112000"/>
-              </a:lnSpc>
-              <a:spcBef>
-                <a:spcPts val="0"/>
-              </a:spcBef>
-              <a:spcAft>
-                <a:spcPts val="0"/>
-              </a:spcAft>
-            </a:pPr>
-            <a:r>
-              <a:rPr sz="1512" b="0">
+              <a:t>Data Analyst · Remote</a:t>
+            </a:r>
+          </a:p>
+        </p:txBody>
+      </p:sp>
+      <p:sp>
+        <p:nvSpPr>
+          <p:cNvPr id="33" name="TextBox 32"/>
+          <p:cNvSpPr txBox="1"/>
+          <p:nvPr/>
+        </p:nvSpPr>
+        <p:spPr>
+          <a:xfrm>
+            <a:off x="5916168" y="5577840"/>
+            <a:ext cx="2706624" cy="228600"/>
+          </a:xfrm>
+          <a:prstGeom prst="rect">
+            <a:avLst/>
+          </a:prstGeom>
+          <a:noFill/>
+        </p:spPr>
+        <p:txBody>
+          <a:bodyPr wrap="square" lIns="0" rIns="0" tIns="0" bIns="0">
+            <a:spAutoFit/>
+          </a:bodyPr>
+          <a:lstStyle/>
+          <a:p>
+            <a:pPr algn="l">
+              <a:lnSpc>
+                <a:spcPct val="112000"/>
+              </a:lnSpc>
+              <a:spcBef>
+                <a:spcPts val="0"/>
+              </a:spcBef>
+              <a:spcAft>
+                <a:spcPts val="0"/>
+              </a:spcAft>
+            </a:pPr>
+            <a:r>
+              <a:rPr sz="1224" b="0">
                 <a:solidFill>
                   <a:srgbClr val="586777"/>
                 </a:solidFill>
                 <a:latin typeface="Segoe UI"/>
               </a:rPr>
-              <a:t>“Cleaned sales data in Excel”</a:t>
-            </a:r>
-          </a:p>
-        </p:txBody>
-      </p:sp>
-      <p:sp>
-        <p:nvSpPr>
-          <p:cNvPr id="31" name="Rounded Rectangle 30"/>
+              <a:t>Example posting · worldwide</a:t>
+            </a:r>
+          </a:p>
+        </p:txBody>
+      </p:sp>
+      <p:sp>
+        <p:nvSpPr>
+          <p:cNvPr id="34" name="Rounded Rectangle 33"/>
           <p:cNvSpPr/>
           <p:nvPr/>
         </p:nvSpPr>
         <p:spPr>
           <a:xfrm>
-            <a:off x="5897880" y="6464808"/>
-            <a:ext cx="2761488" cy="612648"/>
+            <a:off x="5897880" y="5879592"/>
+            <a:ext cx="2761488" cy="804672"/>
           </a:xfrm>
           <a:prstGeom prst="roundRect">
             <a:avLst>
-              <a:gd name="adj" fmla="val 8955"/>
+              <a:gd name="adj" fmla="val 6818"/>
             </a:avLst>
           </a:prstGeom>
           <a:solidFill>
@@ -10969,74 +11326,209 @@
       </p:sp>
       <p:sp>
         <p:nvSpPr>
-          <p:cNvPr id="32" name="TextBox 31"/>
-          <p:cNvSpPr txBox="1"/>
-          <p:nvPr/>
-        </p:nvSpPr>
-        <p:spPr>
-          <a:xfrm>
-            <a:off x="6016752" y="6556248"/>
-            <a:ext cx="2532888" cy="512064"/>
-          </a:xfrm>
-          <a:prstGeom prst="rect">
-            <a:avLst/>
-          </a:prstGeom>
-          <a:noFill/>
-        </p:spPr>
-        <p:txBody>
-          <a:bodyPr wrap="square" lIns="0" rIns="0" tIns="0" bIns="0">
-            <a:spAutoFit/>
-          </a:bodyPr>
-          <a:lstStyle/>
-          <a:p>
-            <a:pPr algn="l">
-              <a:lnSpc>
-                <a:spcPct val="112000"/>
-              </a:lnSpc>
-              <a:spcBef>
-                <a:spcPts val="0"/>
-              </a:spcBef>
-              <a:spcAft>
-                <a:spcPts val="0"/>
-              </a:spcAft>
-            </a:pPr>
-            <a:r>
-              <a:rPr sz="1439" b="0">
+          <p:cNvPr id="35" name="TextBox 34"/>
+          <p:cNvSpPr txBox="1"/>
+          <p:nvPr/>
+        </p:nvSpPr>
+        <p:spPr>
+          <a:xfrm>
+            <a:off x="6016752" y="5952744"/>
+            <a:ext cx="2560320" cy="256032"/>
+          </a:xfrm>
+          <a:prstGeom prst="rect">
+            <a:avLst/>
+          </a:prstGeom>
+          <a:noFill/>
+        </p:spPr>
+        <p:txBody>
+          <a:bodyPr wrap="square" lIns="0" rIns="0" tIns="0" bIns="0">
+            <a:spAutoFit/>
+          </a:bodyPr>
+          <a:lstStyle/>
+          <a:p>
+            <a:pPr algn="l">
+              <a:lnSpc>
+                <a:spcPct val="112000"/>
+              </a:lnSpc>
+              <a:spcBef>
+                <a:spcPts val="0"/>
+              </a:spcBef>
+              <a:spcAft>
+                <a:spcPts val="0"/>
+              </a:spcAft>
+            </a:pPr>
+            <a:r>
+              <a:rPr sz="1584" b="1">
                 <a:solidFill>
                   <a:srgbClr val="1B2D40"/>
                 </a:solidFill>
                 <a:latin typeface="Segoe UI"/>
               </a:rPr>
-              <a:t>Next: practise a SQL JOIN</a:t>
-            </a:r>
-          </a:p>
-          <a:p>
-            <a:pPr algn="l">
-              <a:lnSpc>
-                <a:spcPct val="112000"/>
-              </a:lnSpc>
-              <a:spcBef>
-                <a:spcPts val="0"/>
-              </a:spcBef>
-              <a:spcAft>
-                <a:spcPts val="0"/>
-              </a:spcAft>
-            </a:pPr>
-            <a:r>
-              <a:rPr sz="1439" b="0">
-                <a:solidFill>
-                  <a:srgbClr val="1B2D40"/>
-                </a:solidFill>
-                <a:latin typeface="Segoe UI"/>
-              </a:rPr>
-              <a:t>SQL mentioned in 46.5%*</a:t>
-            </a:r>
-          </a:p>
-        </p:txBody>
-      </p:sp>
-      <p:sp>
-        <p:nvSpPr>
-          <p:cNvPr id="33" name="TextBox 32"/>
+              <a:t>Skill match 67%</a:t>
+            </a:r>
+          </a:p>
+        </p:txBody>
+      </p:sp>
+      <p:sp>
+        <p:nvSpPr>
+          <p:cNvPr id="36" name="TextBox 35"/>
+          <p:cNvSpPr txBox="1"/>
+          <p:nvPr/>
+        </p:nvSpPr>
+        <p:spPr>
+          <a:xfrm>
+            <a:off x="6016752" y="6245352"/>
+            <a:ext cx="2560320" cy="402336"/>
+          </a:xfrm>
+          <a:prstGeom prst="rect">
+            <a:avLst/>
+          </a:prstGeom>
+          <a:noFill/>
+        </p:spPr>
+        <p:txBody>
+          <a:bodyPr wrap="square" lIns="0" rIns="0" tIns="0" bIns="0">
+            <a:spAutoFit/>
+          </a:bodyPr>
+          <a:lstStyle/>
+          <a:p>
+            <a:pPr algn="l">
+              <a:lnSpc>
+                <a:spcPct val="112000"/>
+              </a:lnSpc>
+              <a:spcBef>
+                <a:spcPts val="0"/>
+              </a:spcBef>
+              <a:spcAft>
+                <a:spcPts val="0"/>
+              </a:spcAft>
+            </a:pPr>
+            <a:r>
+              <a:rPr sz="1296" b="0">
+                <a:solidFill>
+                  <a:srgbClr val="586777"/>
+                </a:solidFill>
+                <a:latin typeface="Segoe UI"/>
+              </a:rPr>
+              <a:t>Matched: SQL, Excel</a:t>
+            </a:r>
+          </a:p>
+          <a:p>
+            <a:pPr algn="l">
+              <a:lnSpc>
+                <a:spcPct val="112000"/>
+              </a:lnSpc>
+              <a:spcBef>
+                <a:spcPts val="0"/>
+              </a:spcBef>
+              <a:spcAft>
+                <a:spcPts val="0"/>
+              </a:spcAft>
+            </a:pPr>
+            <a:r>
+              <a:rPr sz="1296" b="0">
+                <a:solidFill>
+                  <a:srgbClr val="586777"/>
+                </a:solidFill>
+                <a:latin typeface="Segoe UI"/>
+              </a:rPr>
+              <a:t>Missing: Python</a:t>
+            </a:r>
+          </a:p>
+        </p:txBody>
+      </p:sp>
+      <p:sp>
+        <p:nvSpPr>
+          <p:cNvPr id="37" name="Rounded Rectangle 36"/>
+          <p:cNvSpPr/>
+          <p:nvPr/>
+        </p:nvSpPr>
+        <p:spPr>
+          <a:xfrm>
+            <a:off x="5897880" y="6784848"/>
+            <a:ext cx="2761488" cy="292608"/>
+          </a:xfrm>
+          <a:prstGeom prst="roundRect">
+            <a:avLst>
+              <a:gd name="adj" fmla="val 15625"/>
+            </a:avLst>
+          </a:prstGeom>
+          <a:solidFill>
+            <a:srgbClr val="F27B43"/>
+          </a:solidFill>
+          <a:ln>
+            <a:noFill/>
+          </a:ln>
+        </p:spPr>
+        <p:style>
+          <a:lnRef idx="1">
+            <a:schemeClr val="accent1"/>
+          </a:lnRef>
+          <a:fillRef idx="3">
+            <a:schemeClr val="accent1"/>
+          </a:fillRef>
+          <a:effectRef idx="2">
+            <a:schemeClr val="accent1"/>
+          </a:effectRef>
+          <a:fontRef idx="minor">
+            <a:schemeClr val="lt1"/>
+          </a:fontRef>
+        </p:style>
+        <p:txBody>
+          <a:bodyPr rtlCol="0" anchor="ctr"/>
+          <a:lstStyle/>
+          <a:p>
+            <a:pPr algn="ctr"/>
+          </a:p>
+        </p:txBody>
+      </p:sp>
+      <p:sp>
+        <p:nvSpPr>
+          <p:cNvPr id="38" name="TextBox 37"/>
+          <p:cNvSpPr txBox="1"/>
+          <p:nvPr/>
+        </p:nvSpPr>
+        <p:spPr>
+          <a:xfrm>
+            <a:off x="5934456" y="6821424"/>
+            <a:ext cx="2688336" cy="228600"/>
+          </a:xfrm>
+          <a:prstGeom prst="rect">
+            <a:avLst/>
+          </a:prstGeom>
+          <a:noFill/>
+        </p:spPr>
+        <p:txBody>
+          <a:bodyPr wrap="square" lIns="0" rIns="0" tIns="0" bIns="0">
+            <a:spAutoFit/>
+          </a:bodyPr>
+          <a:lstStyle/>
+          <a:p>
+            <a:pPr algn="ctr">
+              <a:lnSpc>
+                <a:spcPct val="112000"/>
+              </a:lnSpc>
+              <a:spcBef>
+                <a:spcPts val="0"/>
+              </a:spcBef>
+              <a:spcAft>
+                <a:spcPts val="0"/>
+              </a:spcAft>
+            </a:pPr>
+            <a:r>
+              <a:rPr sz="1296" b="1">
+                <a:solidFill>
+                  <a:srgbClr val="14283F"/>
+                </a:solidFill>
+                <a:latin typeface="Segoe UI"/>
+              </a:rPr>
+              <a:t>Apply on source →</a:t>
+            </a:r>
+          </a:p>
+        </p:txBody>
+      </p:sp>
+      <p:sp>
+        <p:nvSpPr>
+          <p:cNvPr id="39" name="TextBox 38"/>
           <p:cNvSpPr txBox="1"/>
           <p:nvPr/>
         </p:nvSpPr>
@@ -11074,14 +11566,14 @@
                 </a:solidFill>
                 <a:latin typeface="Segoe UI"/>
               </a:rPr>
-              <a:t>03 / Take action</a:t>
-            </a:r>
-          </a:p>
-        </p:txBody>
-      </p:sp>
-      <p:sp>
-        <p:nvSpPr>
-          <p:cNvPr id="34" name="TextBox 33"/>
+              <a:t>03 / Practise</a:t>
+            </a:r>
+          </a:p>
+        </p:txBody>
+      </p:sp>
+      <p:sp>
+        <p:nvSpPr>
+          <p:cNvPr id="40" name="TextBox 39"/>
           <p:cNvSpPr txBox="1"/>
           <p:nvPr/>
         </p:nvSpPr>
@@ -11119,14 +11611,14 @@
                 </a:solidFill>
                 <a:latin typeface="Segoe UI"/>
               </a:rPr>
-              <a:t>Plan + interview practice</a:t>
-            </a:r>
-          </a:p>
-        </p:txBody>
-      </p:sp>
-      <p:sp>
-        <p:nvSpPr>
-          <p:cNvPr id="35" name="Rounded Rectangle 34"/>
+              <a:t>Real questions + AI feedback</a:t>
+            </a:r>
+          </a:p>
+        </p:txBody>
+      </p:sp>
+      <p:sp>
+        <p:nvSpPr>
+          <p:cNvPr id="41" name="Rounded Rectangle 40"/>
           <p:cNvSpPr/>
           <p:nvPr/>
         </p:nvSpPr>
@@ -11171,7 +11663,7 @@
       </p:sp>
       <p:sp>
         <p:nvSpPr>
-          <p:cNvPr id="36" name="Rounded Rectangle 35"/>
+          <p:cNvPr id="42" name="Rounded Rectangle 41"/>
           <p:cNvSpPr/>
           <p:nvPr/>
         </p:nvSpPr>
@@ -11216,7 +11708,7 @@
       </p:sp>
       <p:sp>
         <p:nvSpPr>
-          <p:cNvPr id="37" name="Rounded Rectangle 36"/>
+          <p:cNvPr id="43" name="Rounded Rectangle 42"/>
           <p:cNvSpPr/>
           <p:nvPr/>
         </p:nvSpPr>
@@ -11261,7 +11753,7 @@
       </p:sp>
       <p:sp>
         <p:nvSpPr>
-          <p:cNvPr id="38" name="TextBox 37"/>
+          <p:cNvPr id="44" name="TextBox 43"/>
           <p:cNvSpPr txBox="1"/>
           <p:nvPr/>
         </p:nvSpPr>
@@ -11306,14 +11798,14 @@
       </p:sp>
       <p:sp>
         <p:nvSpPr>
-          <p:cNvPr id="39" name="TextBox 38"/>
-          <p:cNvSpPr txBox="1"/>
-          <p:nvPr/>
-        </p:nvSpPr>
-        <p:spPr>
-          <a:xfrm>
-            <a:off x="10442448" y="5020056"/>
-            <a:ext cx="2670048" cy="292608"/>
+          <p:cNvPr id="45" name="TextBox 44"/>
+          <p:cNvSpPr txBox="1"/>
+          <p:nvPr/>
+        </p:nvSpPr>
+        <p:spPr>
+          <a:xfrm>
+            <a:off x="10442448" y="4983480"/>
+            <a:ext cx="2697480" cy="292608"/>
           </a:xfrm>
           <a:prstGeom prst="rect">
             <a:avLst/>
@@ -11344,114 +11836,137 @@
                 </a:solidFill>
                 <a:latin typeface="Segoe UI"/>
               </a:rPr>
-              <a:t>YOUR SEVEN-DAY PLAN</a:t>
-            </a:r>
-          </a:p>
-        </p:txBody>
-      </p:sp>
-      <p:sp>
-        <p:nvSpPr>
-          <p:cNvPr id="40" name="TextBox 39"/>
-          <p:cNvSpPr txBox="1"/>
-          <p:nvPr/>
-        </p:nvSpPr>
-        <p:spPr>
-          <a:xfrm>
-            <a:off x="10442448" y="5394960"/>
-            <a:ext cx="2706624" cy="969264"/>
-          </a:xfrm>
-          <a:prstGeom prst="rect">
-            <a:avLst/>
-          </a:prstGeom>
-          <a:noFill/>
-        </p:spPr>
-        <p:txBody>
-          <a:bodyPr wrap="square" lIns="0" rIns="0" tIns="0" bIns="0">
-            <a:spAutoFit/>
-          </a:bodyPr>
-          <a:lstStyle/>
-          <a:p>
-            <a:pPr algn="l">
-              <a:lnSpc>
-                <a:spcPct val="112000"/>
-              </a:lnSpc>
-              <a:spcBef>
-                <a:spcPts val="0"/>
-              </a:spcBef>
-              <a:spcAft>
-                <a:spcPts val="0"/>
-              </a:spcAft>
-            </a:pPr>
-            <a:r>
-              <a:rPr sz="1512" b="0">
+              <a:t>FROM THE WEB · SOURCED</a:t>
+            </a:r>
+          </a:p>
+        </p:txBody>
+      </p:sp>
+      <p:sp>
+        <p:nvSpPr>
+          <p:cNvPr id="46" name="TextBox 45"/>
+          <p:cNvSpPr txBox="1"/>
+          <p:nvPr/>
+        </p:nvSpPr>
+        <p:spPr>
+          <a:xfrm>
+            <a:off x="10442448" y="5276088"/>
+            <a:ext cx="2706624" cy="493776"/>
+          </a:xfrm>
+          <a:prstGeom prst="rect">
+            <a:avLst/>
+          </a:prstGeom>
+          <a:noFill/>
+        </p:spPr>
+        <p:txBody>
+          <a:bodyPr wrap="square" lIns="0" rIns="0" tIns="0" bIns="0">
+            <a:spAutoFit/>
+          </a:bodyPr>
+          <a:lstStyle/>
+          <a:p>
+            <a:pPr algn="l">
+              <a:lnSpc>
+                <a:spcPct val="112000"/>
+              </a:lnSpc>
+              <a:spcBef>
+                <a:spcPts val="0"/>
+              </a:spcBef>
+              <a:spcAft>
+                <a:spcPts val="0"/>
+              </a:spcAft>
+            </a:pPr>
+            <a:r>
+              <a:rPr sz="1512" b="1">
                 <a:solidFill>
                   <a:srgbClr val="1B2D40"/>
                 </a:solidFill>
                 <a:latin typeface="Segoe UI"/>
               </a:rPr>
-              <a:t>Day 1  /  Review CV evidence</a:t>
-            </a:r>
-          </a:p>
-          <a:p>
-            <a:pPr algn="l">
-              <a:lnSpc>
-                <a:spcPct val="112000"/>
-              </a:lnSpc>
-              <a:spcBef>
-                <a:spcPts val="0"/>
-              </a:spcBef>
-              <a:spcAft>
-                <a:spcPts val="0"/>
-              </a:spcAft>
-            </a:pPr>
-            <a:r>
-              <a:rPr sz="1512" b="0">
+              <a:t>“How do you handle</a:t>
+            </a:r>
+          </a:p>
+          <a:p>
+            <a:pPr algn="l">
+              <a:lnSpc>
+                <a:spcPct val="112000"/>
+              </a:lnSpc>
+              <a:spcBef>
+                <a:spcPts val="0"/>
+              </a:spcBef>
+              <a:spcAft>
+                <a:spcPts val="0"/>
+              </a:spcAft>
+            </a:pPr>
+            <a:r>
+              <a:rPr sz="1512" b="1">
                 <a:solidFill>
                   <a:srgbClr val="1B2D40"/>
                 </a:solidFill>
                 <a:latin typeface="Segoe UI"/>
               </a:rPr>
-              <a:t>Day 2  /  Build a SQL exercise</a:t>
-            </a:r>
-          </a:p>
-          <a:p>
-            <a:pPr algn="l">
-              <a:lnSpc>
-                <a:spcPct val="112000"/>
-              </a:lnSpc>
-              <a:spcBef>
-                <a:spcPts val="0"/>
-              </a:spcBef>
-              <a:spcAft>
-                <a:spcPts val="0"/>
-              </a:spcAft>
-            </a:pPr>
-            <a:r>
-              <a:rPr sz="1512" b="0">
-                <a:solidFill>
-                  <a:srgbClr val="1B2D40"/>
-                </a:solidFill>
-                <a:latin typeface="Segoe UI"/>
-              </a:rPr>
-              <a:t>Day 3  /  Check edge cases</a:t>
-            </a:r>
-          </a:p>
-        </p:txBody>
-      </p:sp>
-      <p:sp>
-        <p:nvSpPr>
-          <p:cNvPr id="41" name="Rounded Rectangle 40"/>
+              <a:t>missing data?”</a:t>
+            </a:r>
+          </a:p>
+        </p:txBody>
+      </p:sp>
+      <p:sp>
+        <p:nvSpPr>
+          <p:cNvPr id="47" name="TextBox 46"/>
+          <p:cNvSpPr txBox="1"/>
+          <p:nvPr/>
+        </p:nvSpPr>
+        <p:spPr>
+          <a:xfrm>
+            <a:off x="10442448" y="5788152"/>
+            <a:ext cx="2706624" cy="219456"/>
+          </a:xfrm>
+          <a:prstGeom prst="rect">
+            <a:avLst/>
+          </a:prstGeom>
+          <a:noFill/>
+        </p:spPr>
+        <p:txBody>
+          <a:bodyPr wrap="square" lIns="0" rIns="0" tIns="0" bIns="0">
+            <a:spAutoFit/>
+          </a:bodyPr>
+          <a:lstStyle/>
+          <a:p>
+            <a:pPr algn="l">
+              <a:lnSpc>
+                <a:spcPct val="112000"/>
+              </a:lnSpc>
+              <a:spcBef>
+                <a:spcPts val="0"/>
+              </a:spcBef>
+              <a:spcAft>
+                <a:spcPts val="0"/>
+              </a:spcAft>
+            </a:pPr>
+            <a:r>
+              <a:rPr sz="1152" b="0">
+                <a:solidFill>
+                  <a:srgbClr val="586777"/>
+                </a:solidFill>
+                <a:latin typeface="Segoe UI"/>
+              </a:rPr>
+              <a:t>Reported question · source link</a:t>
+            </a:r>
+          </a:p>
+        </p:txBody>
+      </p:sp>
+      <p:sp>
+        <p:nvSpPr>
+          <p:cNvPr id="48" name="Rounded Rectangle 47"/>
           <p:cNvSpPr/>
           <p:nvPr/>
         </p:nvSpPr>
         <p:spPr>
           <a:xfrm>
-            <a:off x="10424160" y="6483096"/>
-            <a:ext cx="2761488" cy="603504"/>
+            <a:off x="10424160" y="6089904"/>
+            <a:ext cx="2761488" cy="987552"/>
           </a:xfrm>
           <a:prstGeom prst="roundRect">
             <a:avLst>
-              <a:gd name="adj" fmla="val 9090"/>
+              <a:gd name="adj" fmla="val 5555"/>
             </a:avLst>
           </a:prstGeom>
           <a:solidFill>
@@ -11485,14 +12000,59 @@
       </p:sp>
       <p:sp>
         <p:nvSpPr>
-          <p:cNvPr id="42" name="TextBox 41"/>
-          <p:cNvSpPr txBox="1"/>
-          <p:nvPr/>
-        </p:nvSpPr>
-        <p:spPr>
-          <a:xfrm>
-            <a:off x="10533888" y="6565392"/>
-            <a:ext cx="2587752" cy="512064"/>
+          <p:cNvPr id="49" name="TextBox 48"/>
+          <p:cNvSpPr txBox="1"/>
+          <p:nvPr/>
+        </p:nvSpPr>
+        <p:spPr>
+          <a:xfrm>
+            <a:off x="10533888" y="6172200"/>
+            <a:ext cx="2587752" cy="237744"/>
+          </a:xfrm>
+          <a:prstGeom prst="rect">
+            <a:avLst/>
+          </a:prstGeom>
+          <a:noFill/>
+        </p:spPr>
+        <p:txBody>
+          <a:bodyPr wrap="square" lIns="0" rIns="0" tIns="0" bIns="0">
+            <a:spAutoFit/>
+          </a:bodyPr>
+          <a:lstStyle/>
+          <a:p>
+            <a:pPr algn="l">
+              <a:lnSpc>
+                <a:spcPct val="112000"/>
+              </a:lnSpc>
+              <a:spcBef>
+                <a:spcPts val="0"/>
+              </a:spcBef>
+              <a:spcAft>
+                <a:spcPts val="0"/>
+              </a:spcAft>
+            </a:pPr>
+            <a:r>
+              <a:rPr sz="1368" b="1">
+                <a:solidFill>
+                  <a:srgbClr val="1B2D40"/>
+                </a:solidFill>
+                <a:latin typeface="Segoe UI"/>
+              </a:rPr>
+              <a:t>Score 3 / 5 · STAR check</a:t>
+            </a:r>
+          </a:p>
+        </p:txBody>
+      </p:sp>
+      <p:sp>
+        <p:nvSpPr>
+          <p:cNvPr id="50" name="TextBox 49"/>
+          <p:cNvSpPr txBox="1"/>
+          <p:nvPr/>
+        </p:nvSpPr>
+        <p:spPr>
+          <a:xfrm>
+            <a:off x="10533888" y="6464808"/>
+            <a:ext cx="2587752" cy="438912"/>
           </a:xfrm>
           <a:prstGeom prst="rect">
             <a:avLst/>
@@ -11523,7 +12083,7 @@
                 </a:solidFill>
                 <a:latin typeface="Segoe UI"/>
               </a:rPr>
-              <a:t>Interview practice</a:t>
+              <a:t>Missing: the Result</a:t>
             </a:r>
           </a:p>
           <a:p>
@@ -11545,14 +12105,14 @@
                 </a:solidFill>
                 <a:latin typeface="Segoe UI"/>
               </a:rPr>
-              <a:t>How do you check duplicates?</a:t>
-            </a:r>
-          </a:p>
-        </p:txBody>
-      </p:sp>
-      <p:sp>
-        <p:nvSpPr>
-          <p:cNvPr id="43" name="TextBox 42"/>
+              <a:t>Add: “…led to [your result]”</a:t>
+            </a:r>
+          </a:p>
+        </p:txBody>
+      </p:sp>
+      <p:sp>
+        <p:nvSpPr>
+          <p:cNvPr id="51" name="TextBox 50"/>
           <p:cNvSpPr txBox="1"/>
           <p:nvPr/>
         </p:nvSpPr>
@@ -11590,7 +12150,7 @@
                 </a:solidFill>
                 <a:latin typeface="Segoe UI"/>
               </a:rPr>
-              <a:t>*Kenya Data Analyst, 2023; n = 391. Tested sample: 39.6% demand-weighted coverage, not hiring odds. Panels illustrative.</a:t>
+              <a:t>Panels illustrative. Skill match % = share of a posting's skills you have, not a hiring probability. Tested brief: 39.6% coverage, n = 391.</a:t>
             </a:r>
           </a:p>
         </p:txBody>
@@ -11794,7 +12354,7 @@
                 </a:solidFill>
                 <a:latin typeface="Segoe UI"/>
               </a:rPr>
-              <a:t>Real public Groq calls · synthetic CVs · strengths, rewrites, seven-day plans and tailored interview questions.</a:t>
+              <a:t>126 unit tests (owner-reported) · 19 new public recording checks · earlier evidence kept separate.</a:t>
             </a:r>
           </a:p>
         </p:txBody>
@@ -11940,12 +12500,12 @@
         </p:nvSpPr>
         <p:spPr>
           <a:xfrm>
-            <a:off x="694944" y="3401568"/>
-            <a:ext cx="6089904" cy="2203704"/>
+            <a:off x="694944" y="3291840"/>
+            <a:ext cx="6089904" cy="2057400"/>
           </a:xfrm>
           <a:prstGeom prst="roundRect">
             <a:avLst>
-              <a:gd name="adj" fmla="val 4979"/>
+              <a:gd name="adj" fmla="val 5333"/>
             </a:avLst>
           </a:prstGeom>
           <a:solidFill>
@@ -11985,7 +12545,7 @@
         </p:nvSpPr>
         <p:spPr>
           <a:xfrm>
-            <a:off x="969264" y="3611880"/>
+            <a:off x="969264" y="3483864"/>
             <a:ext cx="5486400" cy="292608"/>
           </a:xfrm>
           <a:prstGeom prst="rect">
@@ -12030,8 +12590,8 @@
         </p:nvSpPr>
         <p:spPr>
           <a:xfrm>
-            <a:off x="969264" y="4050791"/>
-            <a:ext cx="2468880" cy="896112"/>
+            <a:off x="969264" y="3822191"/>
+            <a:ext cx="2743200" cy="896112"/>
           </a:xfrm>
           <a:prstGeom prst="rect">
             <a:avLst/>
@@ -12062,7 +12622,7 @@
                 </a:solidFill>
                 <a:latin typeface="Georgia"/>
               </a:rPr>
-              <a:t>73</a:t>
+              <a:t>126</a:t>
             </a:r>
           </a:p>
         </p:txBody>
@@ -12075,8 +12635,8 @@
         </p:nvSpPr>
         <p:spPr>
           <a:xfrm>
-            <a:off x="3977639" y="4050791"/>
-            <a:ext cx="2468880" cy="896112"/>
+            <a:off x="3977639" y="3822191"/>
+            <a:ext cx="2560320" cy="896112"/>
           </a:xfrm>
           <a:prstGeom prst="rect">
             <a:avLst/>
@@ -12120,7 +12680,7 @@
         </p:nvSpPr>
         <p:spPr>
           <a:xfrm>
-            <a:off x="1005840" y="5020056"/>
+            <a:off x="1005840" y="4745736"/>
             <a:ext cx="2651760" cy="329184"/>
           </a:xfrm>
           <a:prstGeom prst="rect">
@@ -12165,39 +12725,39 @@
         </p:nvSpPr>
         <p:spPr>
           <a:xfrm>
-            <a:off x="4014215" y="5001768"/>
-            <a:ext cx="2523744" cy="301752"/>
-          </a:xfrm>
-          <a:prstGeom prst="rect">
-            <a:avLst/>
-          </a:prstGeom>
-          <a:noFill/>
-        </p:spPr>
-        <p:txBody>
-          <a:bodyPr wrap="square" lIns="0" rIns="0" tIns="0" bIns="0">
-            <a:spAutoFit/>
-          </a:bodyPr>
-          <a:lstStyle/>
-          <a:p>
-            <a:pPr algn="l">
-              <a:lnSpc>
-                <a:spcPct val="112000"/>
-              </a:lnSpc>
-              <a:spcBef>
-                <a:spcPts val="0"/>
-              </a:spcBef>
-              <a:spcAft>
-                <a:spcPts val="0"/>
-              </a:spcAft>
-            </a:pPr>
-            <a:r>
-              <a:rPr sz="1728" b="0">
+            <a:off x="4014215" y="4736592"/>
+            <a:ext cx="2651760" cy="301752"/>
+          </a:xfrm>
+          <a:prstGeom prst="rect">
+            <a:avLst/>
+          </a:prstGeom>
+          <a:noFill/>
+        </p:spPr>
+        <p:txBody>
+          <a:bodyPr wrap="square" lIns="0" rIns="0" tIns="0" bIns="0">
+            <a:spAutoFit/>
+          </a:bodyPr>
+          <a:lstStyle/>
+          <a:p>
+            <a:pPr algn="l">
+              <a:lnSpc>
+                <a:spcPct val="112000"/>
+              </a:lnSpc>
+              <a:spcBef>
+                <a:spcPts val="0"/>
+              </a:spcBef>
+              <a:spcAft>
+                <a:spcPts val="0"/>
+              </a:spcAft>
+            </a:pPr>
+            <a:r>
+              <a:rPr sz="1655" b="0">
                 <a:solidFill>
                   <a:srgbClr val="D4DEE6"/>
                 </a:solidFill>
                 <a:latin typeface="Segoe UI"/>
               </a:rPr>
-              <a:t>public assertions</a:t>
+              <a:t>earlier public checks</a:t>
             </a:r>
           </a:p>
         </p:txBody>
@@ -12210,8 +12770,8 @@
         </p:nvSpPr>
         <p:spPr>
           <a:xfrm>
-            <a:off x="4014215" y="5330952"/>
-            <a:ext cx="2542032" cy="228600"/>
+            <a:off x="4014215" y="5056632"/>
+            <a:ext cx="2651760" cy="228600"/>
           </a:xfrm>
           <a:prstGeom prst="rect">
             <a:avLst/>
@@ -12255,12 +12815,12 @@
         </p:nvSpPr>
         <p:spPr>
           <a:xfrm>
-            <a:off x="7132320" y="3401568"/>
-            <a:ext cx="6839712" cy="2203704"/>
+            <a:off x="7132320" y="3291840"/>
+            <a:ext cx="6839712" cy="2057400"/>
           </a:xfrm>
           <a:prstGeom prst="roundRect">
             <a:avLst>
-              <a:gd name="adj" fmla="val 4979"/>
+              <a:gd name="adj" fmla="val 5333"/>
             </a:avLst>
           </a:prstGeom>
           <a:solidFill>
@@ -12300,8 +12860,8 @@
         </p:nvSpPr>
         <p:spPr>
           <a:xfrm>
-            <a:off x="7424927" y="3611880"/>
-            <a:ext cx="6217920" cy="292608"/>
+            <a:off x="7424927" y="3483864"/>
+            <a:ext cx="6309360" cy="292608"/>
           </a:xfrm>
           <a:prstGeom prst="rect">
             <a:avLst/>
@@ -12332,7 +12892,7 @@
                 </a:solidFill>
                 <a:latin typeface="Segoe UI"/>
               </a:rPr>
-              <a:t>LIVE GROQ / OBSERVED RESPONSE TIMES</a:t>
+              <a:t>NEW PUBLIC RECORDING / GROQ · GPT-OSS-20B</a:t>
             </a:r>
           </a:p>
         </p:txBody>
@@ -12345,8 +12905,8 @@
         </p:nvSpPr>
         <p:spPr>
           <a:xfrm>
-            <a:off x="7424927" y="4123944"/>
-            <a:ext cx="6199632" cy="1005840"/>
+            <a:off x="7424927" y="3877056"/>
+            <a:ext cx="6309360" cy="914400"/>
           </a:xfrm>
           <a:prstGeom prst="rect">
             <a:avLst/>
@@ -12377,7 +12937,7 @@
                 </a:solidFill>
                 <a:latin typeface="Segoe UI"/>
               </a:rPr>
-              <a:t>2.259s desktop  /  1.318s mobile</a:t>
+              <a:t>1.271s PDF + follow-ups / 1.450s brief</a:t>
             </a:r>
           </a:p>
           <a:p>
@@ -12399,7 +12959,7 @@
                 </a:solidFill>
                 <a:latin typeface="Segoe UI"/>
               </a:rPr>
-              <a:t>2.260s recording, including PDF processing</a:t>
+              <a:t>0.844s feedback · score 4/5</a:t>
             </a:r>
           </a:p>
           <a:p>
@@ -12421,7 +12981,7 @@
                 </a:solidFill>
                 <a:latin typeface="Segoe UI"/>
               </a:rPr>
-              <a:t>0 JavaScript errors across these runs</a:t>
+              <a:t>0 JavaScript errors · 90s video · 1× playback</a:t>
             </a:r>
           </a:p>
         </p:txBody>
@@ -12434,8 +12994,8 @@
         </p:nvSpPr>
         <p:spPr>
           <a:xfrm>
-            <a:off x="7424927" y="5303520"/>
-            <a:ext cx="6199632" cy="246888"/>
+            <a:off x="7424927" y="4937760"/>
+            <a:ext cx="6309360" cy="246888"/>
           </a:xfrm>
           <a:prstGeom prst="rect">
             <a:avLst/>
@@ -12466,158 +13026,336 @@
                 </a:solidFill>
                 <a:latin typeface="Segoe UI"/>
               </a:rPr>
-              <a:t>Individual observations, not a performance benchmark.</a:t>
-            </a:r>
-          </a:p>
-        </p:txBody>
-      </p:sp>
-      <p:sp>
-        <p:nvSpPr>
-          <p:cNvPr id="20" name="TextBox 19"/>
-          <p:cNvSpPr txBox="1"/>
-          <p:nvPr/>
-        </p:nvSpPr>
-        <p:spPr>
-          <a:xfrm>
-            <a:off x="694944" y="6099048"/>
-            <a:ext cx="4133087" cy="393192"/>
-          </a:xfrm>
-          <a:prstGeom prst="rect">
-            <a:avLst/>
-          </a:prstGeom>
-          <a:noFill/>
-        </p:spPr>
-        <p:txBody>
-          <a:bodyPr wrap="square" lIns="0" rIns="0" tIns="0" bIns="0">
-            <a:spAutoFit/>
-          </a:bodyPr>
-          <a:lstStyle/>
-          <a:p>
-            <a:pPr algn="l">
-              <a:lnSpc>
-                <a:spcPct val="112000"/>
-              </a:lnSpc>
-              <a:spcBef>
-                <a:spcPts val="0"/>
-              </a:spcBef>
-              <a:spcAft>
-                <a:spcPts val="0"/>
-              </a:spcAft>
-            </a:pPr>
-            <a:r>
-              <a:rPr sz="2160" b="1">
+              <a:t>Observed once; NVIDIA API Catalog backup not exercised.</a:t>
+            </a:r>
+          </a:p>
+        </p:txBody>
+      </p:sp>
+      <p:sp>
+        <p:nvSpPr>
+          <p:cNvPr id="20" name="Rounded Rectangle 19"/>
+          <p:cNvSpPr/>
+          <p:nvPr/>
+        </p:nvSpPr>
+        <p:spPr>
+          <a:xfrm>
+            <a:off x="694944" y="5513832"/>
+            <a:ext cx="13277088" cy="731520"/>
+          </a:xfrm>
+          <a:prstGeom prst="roundRect">
+            <a:avLst>
+              <a:gd name="adj" fmla="val 12500"/>
+            </a:avLst>
+          </a:prstGeom>
+          <a:solidFill>
+            <a:srgbClr val="FFFFFF"/>
+          </a:solidFill>
+          <a:ln>
+            <a:noFill/>
+          </a:ln>
+        </p:spPr>
+        <p:style>
+          <a:lnRef idx="1">
+            <a:schemeClr val="accent1"/>
+          </a:lnRef>
+          <a:fillRef idx="3">
+            <a:schemeClr val="accent1"/>
+          </a:fillRef>
+          <a:effectRef idx="2">
+            <a:schemeClr val="accent1"/>
+          </a:effectRef>
+          <a:fontRef idx="minor">
+            <a:schemeClr val="lt1"/>
+          </a:fontRef>
+        </p:style>
+        <p:txBody>
+          <a:bodyPr rtlCol="0" anchor="ctr"/>
+          <a:lstStyle/>
+          <a:p>
+            <a:pPr algn="ctr"/>
+          </a:p>
+        </p:txBody>
+      </p:sp>
+      <p:sp>
+        <p:nvSpPr>
+          <p:cNvPr id="21" name="Rectangle 20"/>
+          <p:cNvSpPr/>
+          <p:nvPr/>
+        </p:nvSpPr>
+        <p:spPr>
+          <a:xfrm>
+            <a:off x="694944" y="5513832"/>
+            <a:ext cx="54864" cy="731520"/>
+          </a:xfrm>
+          <a:prstGeom prst="rect">
+            <a:avLst/>
+          </a:prstGeom>
+          <a:solidFill>
+            <a:srgbClr val="F27B43"/>
+          </a:solidFill>
+          <a:ln>
+            <a:noFill/>
+          </a:ln>
+        </p:spPr>
+        <p:style>
+          <a:lnRef idx="1">
+            <a:schemeClr val="accent1"/>
+          </a:lnRef>
+          <a:fillRef idx="3">
+            <a:schemeClr val="accent1"/>
+          </a:fillRef>
+          <a:effectRef idx="2">
+            <a:schemeClr val="accent1"/>
+          </a:effectRef>
+          <a:fontRef idx="minor">
+            <a:schemeClr val="lt1"/>
+          </a:fontRef>
+        </p:style>
+        <p:txBody>
+          <a:bodyPr rtlCol="0" anchor="ctr"/>
+          <a:lstStyle/>
+          <a:p>
+            <a:pPr algn="ctr"/>
+          </a:p>
+        </p:txBody>
+      </p:sp>
+      <p:sp>
+        <p:nvSpPr>
+          <p:cNvPr id="22" name="TextBox 21"/>
+          <p:cNvSpPr txBox="1"/>
+          <p:nvPr/>
+        </p:nvSpPr>
+        <p:spPr>
+          <a:xfrm>
+            <a:off x="969264" y="5605272"/>
+            <a:ext cx="12801600" cy="292608"/>
+          </a:xfrm>
+          <a:prstGeom prst="rect">
+            <a:avLst/>
+          </a:prstGeom>
+          <a:noFill/>
+        </p:spPr>
+        <p:txBody>
+          <a:bodyPr wrap="square" lIns="0" rIns="0" tIns="0" bIns="0">
+            <a:spAutoFit/>
+          </a:bodyPr>
+          <a:lstStyle/>
+          <a:p>
+            <a:pPr algn="l">
+              <a:lnSpc>
+                <a:spcPct val="112000"/>
+              </a:lnSpc>
+              <a:spcBef>
+                <a:spcPts val="0"/>
+              </a:spcBef>
+              <a:spcAft>
+                <a:spcPts val="0"/>
+              </a:spcAft>
+            </a:pPr>
+            <a:r>
+              <a:rPr sz="1368" b="1">
                 <a:solidFill>
                   <a:srgbClr val="1B2D40"/>
                 </a:solidFill>
+                <a:latin typeface="Segoe UI"/>
+              </a:rPr>
+              <a:t>NEW TODAY / FOLLOW-UPS · LIVE JOBS · WEB INTERVIEW QUESTIONS · ANSWER FEEDBACK</a:t>
+            </a:r>
+          </a:p>
+        </p:txBody>
+      </p:sp>
+      <p:sp>
+        <p:nvSpPr>
+          <p:cNvPr id="23" name="TextBox 22"/>
+          <p:cNvSpPr txBox="1"/>
+          <p:nvPr/>
+        </p:nvSpPr>
+        <p:spPr>
+          <a:xfrm>
+            <a:off x="969264" y="5897880"/>
+            <a:ext cx="12801600" cy="256032"/>
+          </a:xfrm>
+          <a:prstGeom prst="rect">
+            <a:avLst/>
+          </a:prstGeom>
+          <a:noFill/>
+        </p:spPr>
+        <p:txBody>
+          <a:bodyPr wrap="square" lIns="0" rIns="0" tIns="0" bIns="0">
+            <a:spAutoFit/>
+          </a:bodyPr>
+          <a:lstStyle/>
+          <a:p>
+            <a:pPr algn="l">
+              <a:lnSpc>
+                <a:spcPct val="112000"/>
+              </a:lnSpc>
+              <a:spcBef>
+                <a:spcPts val="0"/>
+              </a:spcBef>
+              <a:spcAft>
+                <a:spcPts val="0"/>
+              </a:spcAft>
+            </a:pPr>
+            <a:r>
+              <a:rPr sz="1512" b="0">
+                <a:solidFill>
+                  <a:srgbClr val="586777"/>
+                </a:solidFill>
+                <a:latin typeface="Segoe UI"/>
+              </a:rPr>
+              <a:t>8 remote + 3 local job cards shown  ·  8 source-linked interview questions  ·  19 new recording checks passed</a:t>
+            </a:r>
+          </a:p>
+        </p:txBody>
+      </p:sp>
+      <p:sp>
+        <p:nvSpPr>
+          <p:cNvPr id="24" name="TextBox 23"/>
+          <p:cNvSpPr txBox="1"/>
+          <p:nvPr/>
+        </p:nvSpPr>
+        <p:spPr>
+          <a:xfrm>
+            <a:off x="694944" y="6419088"/>
+            <a:ext cx="4297680" cy="365760"/>
+          </a:xfrm>
+          <a:prstGeom prst="rect">
+            <a:avLst/>
+          </a:prstGeom>
+          <a:noFill/>
+        </p:spPr>
+        <p:txBody>
+          <a:bodyPr wrap="square" lIns="0" rIns="0" tIns="0" bIns="0">
+            <a:spAutoFit/>
+          </a:bodyPr>
+          <a:lstStyle/>
+          <a:p>
+            <a:pPr algn="l">
+              <a:lnSpc>
+                <a:spcPct val="112000"/>
+              </a:lnSpc>
+              <a:spcBef>
+                <a:spcPts val="0"/>
+              </a:spcBef>
+              <a:spcAft>
+                <a:spcPts val="0"/>
+              </a:spcAft>
+            </a:pPr>
+            <a:r>
+              <a:rPr sz="2016" b="1">
+                <a:solidFill>
+                  <a:srgbClr val="1B2D40"/>
+                </a:solidFill>
                 <a:latin typeface="Georgia"/>
               </a:rPr>
-              <a:t>Data</a:t>
-            </a:r>
-          </a:p>
-        </p:txBody>
-      </p:sp>
-      <p:sp>
-        <p:nvSpPr>
-          <p:cNvPr id="21" name="TextBox 20"/>
-          <p:cNvSpPr txBox="1"/>
-          <p:nvPr/>
-        </p:nvSpPr>
-        <p:spPr>
-          <a:xfrm>
-            <a:off x="694944" y="6647688"/>
-            <a:ext cx="4169663" cy="658368"/>
-          </a:xfrm>
-          <a:prstGeom prst="rect">
-            <a:avLst/>
-          </a:prstGeom>
-          <a:noFill/>
-        </p:spPr>
-        <p:txBody>
-          <a:bodyPr wrap="square" lIns="0" rIns="0" tIns="0" bIns="0">
-            <a:spAutoFit/>
-          </a:bodyPr>
-          <a:lstStyle/>
-          <a:p>
-            <a:pPr algn="l">
-              <a:lnSpc>
-                <a:spcPct val="112000"/>
-              </a:lnSpc>
-              <a:spcBef>
-                <a:spcPts val="0"/>
-              </a:spcBef>
-              <a:spcAft>
-                <a:spcPts val="0"/>
-              </a:spcAft>
-            </a:pPr>
-            <a:r>
-              <a:rPr sz="1655" b="0">
+              <a:t>Data + match %</a:t>
+            </a:r>
+          </a:p>
+        </p:txBody>
+      </p:sp>
+      <p:sp>
+        <p:nvSpPr>
+          <p:cNvPr id="25" name="TextBox 24"/>
+          <p:cNvSpPr txBox="1"/>
+          <p:nvPr/>
+        </p:nvSpPr>
+        <p:spPr>
+          <a:xfrm>
+            <a:off x="694944" y="6821424"/>
+            <a:ext cx="4297680" cy="475488"/>
+          </a:xfrm>
+          <a:prstGeom prst="rect">
+            <a:avLst/>
+          </a:prstGeom>
+          <a:noFill/>
+        </p:spPr>
+        <p:txBody>
+          <a:bodyPr wrap="square" lIns="0" rIns="0" tIns="0" bIns="0">
+            <a:spAutoFit/>
+          </a:bodyPr>
+          <a:lstStyle/>
+          <a:p>
+            <a:pPr algn="l">
+              <a:lnSpc>
+                <a:spcPct val="112000"/>
+              </a:lnSpc>
+              <a:spcBef>
+                <a:spcPts val="0"/>
+              </a:spcBef>
+              <a:spcAft>
+                <a:spcPts val="0"/>
+              </a:spcAft>
+            </a:pPr>
+            <a:r>
+              <a:rPr sz="1512" b="0">
                 <a:solidFill>
                   <a:srgbClr val="586777"/>
                 </a:solidFill>
                 <a:latin typeface="Segoe UI"/>
               </a:rPr>
-              <a:t>2023 sample, uneven country coverage.</a:t>
-            </a:r>
-          </a:p>
-          <a:p>
-            <a:pPr algn="l">
-              <a:lnSpc>
-                <a:spcPct val="112000"/>
-              </a:lnSpc>
-              <a:spcBef>
-                <a:spcPts val="0"/>
-              </a:spcBef>
-              <a:spcAft>
-                <a:spcPts val="0"/>
-              </a:spcAft>
-            </a:pPr>
-            <a:r>
-              <a:rPr sz="1655" b="0">
+              <a:t>2023 sample sets the priorities.</a:t>
+            </a:r>
+          </a:p>
+          <a:p>
+            <a:pPr algn="l">
+              <a:lnSpc>
+                <a:spcPct val="112000"/>
+              </a:lnSpc>
+              <a:spcBef>
+                <a:spcPts val="0"/>
+              </a:spcBef>
+              <a:spcAft>
+                <a:spcPts val="0"/>
+              </a:spcAft>
+            </a:pPr>
+            <a:r>
+              <a:rPr sz="1512" b="0">
                 <a:solidFill>
                   <a:srgbClr val="586777"/>
                 </a:solidFill>
                 <a:latin typeface="Segoe UI"/>
               </a:rPr>
-              <a:t>Not live vacancies or hiring probabilities.</a:t>
-            </a:r>
-          </a:p>
-        </p:txBody>
-      </p:sp>
-      <p:sp>
-        <p:nvSpPr>
-          <p:cNvPr id="22" name="TextBox 21"/>
-          <p:cNvSpPr txBox="1"/>
-          <p:nvPr/>
-        </p:nvSpPr>
-        <p:spPr>
-          <a:xfrm>
-            <a:off x="5239512" y="6099048"/>
-            <a:ext cx="4133087" cy="393192"/>
-          </a:xfrm>
-          <a:prstGeom prst="rect">
-            <a:avLst/>
-          </a:prstGeom>
-          <a:noFill/>
-        </p:spPr>
-        <p:txBody>
-          <a:bodyPr wrap="square" lIns="0" rIns="0" tIns="0" bIns="0">
-            <a:spAutoFit/>
-          </a:bodyPr>
-          <a:lstStyle/>
-          <a:p>
-            <a:pPr algn="l">
-              <a:lnSpc>
-                <a:spcPct val="112000"/>
-              </a:lnSpc>
-              <a:spcBef>
-                <a:spcPts val="0"/>
-              </a:spcBef>
-              <a:spcAft>
-                <a:spcPts val="0"/>
-              </a:spcAft>
-            </a:pPr>
-            <a:r>
-              <a:rPr sz="2160" b="1">
+              <a:t>Match % is not a hiring probability.</a:t>
+            </a:r>
+          </a:p>
+        </p:txBody>
+      </p:sp>
+      <p:sp>
+        <p:nvSpPr>
+          <p:cNvPr id="26" name="TextBox 25"/>
+          <p:cNvSpPr txBox="1"/>
+          <p:nvPr/>
+        </p:nvSpPr>
+        <p:spPr>
+          <a:xfrm>
+            <a:off x="5239512" y="6419088"/>
+            <a:ext cx="4297680" cy="365760"/>
+          </a:xfrm>
+          <a:prstGeom prst="rect">
+            <a:avLst/>
+          </a:prstGeom>
+          <a:noFill/>
+        </p:spPr>
+        <p:txBody>
+          <a:bodyPr wrap="square" lIns="0" rIns="0" tIns="0" bIns="0">
+            <a:spAutoFit/>
+          </a:bodyPr>
+          <a:lstStyle/>
+          <a:p>
+            <a:pPr algn="l">
+              <a:lnSpc>
+                <a:spcPct val="112000"/>
+              </a:lnSpc>
+              <a:spcBef>
+                <a:spcPts val="0"/>
+              </a:spcBef>
+              <a:spcAft>
+                <a:spcPts val="0"/>
+              </a:spcAft>
+            </a:pPr>
+            <a:r>
+              <a:rPr sz="2016" b="1">
                 <a:solidFill>
                   <a:srgbClr val="1B2D40"/>
                 </a:solidFill>
@@ -12630,39 +13368,39 @@
       </p:sp>
       <p:sp>
         <p:nvSpPr>
-          <p:cNvPr id="23" name="TextBox 22"/>
-          <p:cNvSpPr txBox="1"/>
-          <p:nvPr/>
-        </p:nvSpPr>
-        <p:spPr>
-          <a:xfrm>
-            <a:off x="5239512" y="6647688"/>
-            <a:ext cx="4169663" cy="658368"/>
-          </a:xfrm>
-          <a:prstGeom prst="rect">
-            <a:avLst/>
-          </a:prstGeom>
-          <a:noFill/>
-        </p:spPr>
-        <p:txBody>
-          <a:bodyPr wrap="square" lIns="0" rIns="0" tIns="0" bIns="0">
-            <a:spAutoFit/>
-          </a:bodyPr>
-          <a:lstStyle/>
-          <a:p>
-            <a:pPr algn="l">
-              <a:lnSpc>
-                <a:spcPct val="112000"/>
-              </a:lnSpc>
-              <a:spcBef>
-                <a:spcPts val="0"/>
-              </a:spcBef>
-              <a:spcAft>
-                <a:spcPts val="0"/>
-              </a:spcAft>
-            </a:pPr>
-            <a:r>
-              <a:rPr sz="1655" b="0">
+          <p:cNvPr id="27" name="TextBox 26"/>
+          <p:cNvSpPr txBox="1"/>
+          <p:nvPr/>
+        </p:nvSpPr>
+        <p:spPr>
+          <a:xfrm>
+            <a:off x="5239512" y="6821424"/>
+            <a:ext cx="4297680" cy="475488"/>
+          </a:xfrm>
+          <a:prstGeom prst="rect">
+            <a:avLst/>
+          </a:prstGeom>
+          <a:noFill/>
+        </p:spPr>
+        <p:txBody>
+          <a:bodyPr wrap="square" lIns="0" rIns="0" tIns="0" bIns="0">
+            <a:spAutoFit/>
+          </a:bodyPr>
+          <a:lstStyle/>
+          <a:p>
+            <a:pPr algn="l">
+              <a:lnSpc>
+                <a:spcPct val="112000"/>
+              </a:lnSpc>
+              <a:spcBef>
+                <a:spcPts val="0"/>
+              </a:spcBef>
+              <a:spcAft>
+                <a:spcPts val="0"/>
+              </a:spcAft>
+            </a:pPr>
+            <a:r>
+              <a:rPr sz="1512" b="0">
                 <a:solidFill>
                   <a:srgbClr val="586777"/>
                 </a:solidFill>
@@ -12684,52 +13422,52 @@
               </a:spcAft>
             </a:pPr>
             <a:r>
-              <a:rPr sz="1655" b="0">
+              <a:rPr sz="1512" b="0">
                 <a:solidFill>
                   <a:srgbClr val="586777"/>
                 </a:solidFill>
                 <a:latin typeface="Segoe UI"/>
               </a:rPr>
-              <a:t>business-impact claims can still slip through.</a:t>
-            </a:r>
-          </a:p>
-        </p:txBody>
-      </p:sp>
-      <p:sp>
-        <p:nvSpPr>
-          <p:cNvPr id="24" name="TextBox 23"/>
-          <p:cNvSpPr txBox="1"/>
-          <p:nvPr/>
-        </p:nvSpPr>
-        <p:spPr>
-          <a:xfrm>
-            <a:off x="9784080" y="6099048"/>
-            <a:ext cx="4133087" cy="393192"/>
-          </a:xfrm>
-          <a:prstGeom prst="rect">
-            <a:avLst/>
-          </a:prstGeom>
-          <a:noFill/>
-        </p:spPr>
-        <p:txBody>
-          <a:bodyPr wrap="square" lIns="0" rIns="0" tIns="0" bIns="0">
-            <a:spAutoFit/>
-          </a:bodyPr>
-          <a:lstStyle/>
-          <a:p>
-            <a:pPr algn="l">
-              <a:lnSpc>
-                <a:spcPct val="112000"/>
-              </a:lnSpc>
-              <a:spcBef>
-                <a:spcPts val="0"/>
-              </a:spcBef>
-              <a:spcAft>
-                <a:spcPts val="0"/>
-              </a:spcAft>
-            </a:pPr>
-            <a:r>
-              <a:rPr sz="2160" b="1">
+              <a:t>claims can still slip through.</a:t>
+            </a:r>
+          </a:p>
+        </p:txBody>
+      </p:sp>
+      <p:sp>
+        <p:nvSpPr>
+          <p:cNvPr id="28" name="TextBox 27"/>
+          <p:cNvSpPr txBox="1"/>
+          <p:nvPr/>
+        </p:nvSpPr>
+        <p:spPr>
+          <a:xfrm>
+            <a:off x="9784080" y="6419088"/>
+            <a:ext cx="4297680" cy="365760"/>
+          </a:xfrm>
+          <a:prstGeom prst="rect">
+            <a:avLst/>
+          </a:prstGeom>
+          <a:noFill/>
+        </p:spPr>
+        <p:txBody>
+          <a:bodyPr wrap="square" lIns="0" rIns="0" tIns="0" bIns="0">
+            <a:spAutoFit/>
+          </a:bodyPr>
+          <a:lstStyle/>
+          <a:p>
+            <a:pPr algn="l">
+              <a:lnSpc>
+                <a:spcPct val="112000"/>
+              </a:lnSpc>
+              <a:spcBef>
+                <a:spcPts val="0"/>
+              </a:spcBef>
+              <a:spcAft>
+                <a:spcPts val="0"/>
+              </a:spcAft>
+            </a:pPr>
+            <a:r>
+              <a:rPr sz="2016" b="1">
                 <a:solidFill>
                   <a:srgbClr val="1B2D40"/>
                 </a:solidFill>
@@ -12742,39 +13480,39 @@
       </p:sp>
       <p:sp>
         <p:nvSpPr>
-          <p:cNvPr id="25" name="TextBox 24"/>
-          <p:cNvSpPr txBox="1"/>
-          <p:nvPr/>
-        </p:nvSpPr>
-        <p:spPr>
-          <a:xfrm>
-            <a:off x="9784080" y="6647688"/>
-            <a:ext cx="4169663" cy="658368"/>
-          </a:xfrm>
-          <a:prstGeom prst="rect">
-            <a:avLst/>
-          </a:prstGeom>
-          <a:noFill/>
-        </p:spPr>
-        <p:txBody>
-          <a:bodyPr wrap="square" lIns="0" rIns="0" tIns="0" bIns="0">
-            <a:spAutoFit/>
-          </a:bodyPr>
-          <a:lstStyle/>
-          <a:p>
-            <a:pPr algn="l">
-              <a:lnSpc>
-                <a:spcPct val="112000"/>
-              </a:lnSpc>
-              <a:spcBef>
-                <a:spcPts val="0"/>
-              </a:spcBef>
-              <a:spcAft>
-                <a:spcPts val="0"/>
-              </a:spcAft>
-            </a:pPr>
-            <a:r>
-              <a:rPr sz="1655" b="0">
+          <p:cNvPr id="29" name="TextBox 28"/>
+          <p:cNvSpPr txBox="1"/>
+          <p:nvPr/>
+        </p:nvSpPr>
+        <p:spPr>
+          <a:xfrm>
+            <a:off x="9784080" y="6821424"/>
+            <a:ext cx="4297680" cy="475488"/>
+          </a:xfrm>
+          <a:prstGeom prst="rect">
+            <a:avLst/>
+          </a:prstGeom>
+          <a:noFill/>
+        </p:spPr>
+        <p:txBody>
+          <a:bodyPr wrap="square" lIns="0" rIns="0" tIns="0" bIns="0">
+            <a:spAutoFit/>
+          </a:bodyPr>
+          <a:lstStyle/>
+          <a:p>
+            <a:pPr algn="l">
+              <a:lnSpc>
+                <a:spcPct val="112000"/>
+              </a:lnSpc>
+              <a:spcBef>
+                <a:spcPts val="0"/>
+              </a:spcBef>
+              <a:spcAft>
+                <a:spcPts val="0"/>
+              </a:spcAft>
+            </a:pPr>
+            <a:r>
+              <a:rPr sz="1512" b="0">
                 <a:solidFill>
                   <a:srgbClr val="586777"/>
                 </a:solidFill>
@@ -12796,7 +13534,7 @@
               </a:spcAft>
             </a:pPr>
             <a:r>
-              <a:rPr sz="1655" b="0">
+              <a:rPr sz="1512" b="0">
                 <a:solidFill>
                   <a:srgbClr val="586777"/>
                 </a:solidFill>
@@ -13286,7 +14024,7 @@
         <p:spPr>
           <a:xfrm>
             <a:off x="694944" y="5120640"/>
-            <a:ext cx="4160520" cy="886968"/>
+            <a:ext cx="4251960" cy="886968"/>
           </a:xfrm>
           <a:prstGeom prst="rect">
             <a:avLst/>
@@ -13486,7 +14224,7 @@
         <p:spPr>
           <a:xfrm>
             <a:off x="5239512" y="5120640"/>
-            <a:ext cx="4160520" cy="886968"/>
+            <a:ext cx="4251960" cy="886968"/>
           </a:xfrm>
           <a:prstGeom prst="rect">
             <a:avLst/>
@@ -13517,7 +14255,7 @@
                 </a:solidFill>
                 <a:latin typeface="Segoe UI"/>
               </a:rPr>
-              <a:t>Check whether rewrites preserve facts</a:t>
+              <a:t>Check that rewrites keep the facts</a:t>
             </a:r>
           </a:p>
           <a:p>
@@ -13539,7 +14277,7 @@
                 </a:solidFill>
                 <a:latin typeface="Segoe UI"/>
               </a:rPr>
-              <a:t>and priorities are understandable.</a:t>
+              <a:t>and job matches are relevant.</a:t>
             </a:r>
           </a:p>
         </p:txBody>
@@ -13686,7 +14424,7 @@
         <p:spPr>
           <a:xfrm>
             <a:off x="9784080" y="5120640"/>
-            <a:ext cx="4160520" cy="886968"/>
+            <a:ext cx="4251960" cy="886968"/>
           </a:xfrm>
           <a:prstGeom prst="rect">
             <a:avLst/>
@@ -13717,7 +14455,7 @@
                 </a:solidFill>
                 <a:latin typeface="Segoe UI"/>
               </a:rPr>
-              <a:t>Count completed practice artifacts.</a:t>
+              <a:t>Count practice answers and</a:t>
             </a:r>
           </a:p>
           <a:p>
@@ -13739,7 +14477,29 @@
                 </a:solidFill>
                 <a:latin typeface="Segoe UI"/>
               </a:rPr>
-              <a:t>Ask what helped and what blocked progress.</a:t>
+              <a:t>applications started. Ask what</a:t>
+            </a:r>
+          </a:p>
+          <a:p>
+            <a:pPr algn="l">
+              <a:lnSpc>
+                <a:spcPct val="112000"/>
+              </a:lnSpc>
+              <a:spcBef>
+                <a:spcPts val="0"/>
+              </a:spcBef>
+              <a:spcAft>
+                <a:spcPts val="0"/>
+              </a:spcAft>
+            </a:pPr>
+            <a:r>
+              <a:rPr sz="1728" b="0">
+                <a:solidFill>
+                  <a:srgbClr val="586777"/>
+                </a:solidFill>
+                <a:latin typeface="Segoe UI"/>
+              </a:rPr>
+              <a:t>helped and what blocked progress.</a:t>
             </a:r>
           </a:p>
         </p:txBody>
@@ -13842,8 +14602,8 @@
         </p:nvSpPr>
         <p:spPr>
           <a:xfrm>
-            <a:off x="6217920" y="6455664"/>
-            <a:ext cx="7360920" cy="347472"/>
+            <a:off x="6035040" y="6455664"/>
+            <a:ext cx="7680960" cy="347472"/>
           </a:xfrm>
           <a:prstGeom prst="rect">
             <a:avLst/>
@@ -13874,7 +14634,7 @@
                 </a:solidFill>
                 <a:latin typeface="Segoe UI"/>
               </a:rPr>
-              <a:t>Mobile-first guidance for Kenyan learners.</a:t>
+              <a:t>Mobile-first coaching for Kenyan learners.</a:t>
             </a:r>
           </a:p>
         </p:txBody>
@@ -13888,7 +14648,7 @@
         <p:spPr>
           <a:xfrm>
             <a:off x="987552" y="6922008"/>
-            <a:ext cx="12655296" cy="256032"/>
+            <a:ext cx="12801600" cy="256032"/>
           </a:xfrm>
           <a:prstGeom prst="rect">
             <a:avLst/>
@@ -14301,7 +15061,7 @@
                 </a:solidFill>
                 <a:latin typeface="Georgia"/>
               </a:rPr>
-              <a:t>Your evidence. Your market. Your next seven days.</a:t>
+              <a:t>Ask. Match. Practise. Your next move.</a:t>
             </a:r>
           </a:p>
         </p:txBody>
@@ -14753,7 +15513,7 @@
                 <a:latin typeface="Segoe UI"/>
                 <a:hlinkClick r:id="rId4"/>
               </a:rPr>
-              <a:t>njia-demo-90s.webm · published</a:t>
+              <a:t>njia-demo-90s.mp4 · published</a:t>
             </a:r>
           </a:p>
         </p:txBody>
@@ -14767,7 +15527,7 @@
         <p:spPr>
           <a:xfrm>
             <a:off x="731520" y="7022592"/>
-            <a:ext cx="6309360" cy="338328"/>
+            <a:ext cx="6400800" cy="338328"/>
           </a:xfrm>
           <a:prstGeom prst="rect">
             <a:avLst/>

</xml_diff>